<commit_message>
Detail pilot cost slide; remove internal reference docs
- Cost slide: AWS component breakdown (~Rs 50,900/mo pilot), unit
  economics (ROI 2.4x), one-time setup note
- Drop internal spec, problem statement and deck template from the
  public repo
</commit_message>
<xml_diff>
--- a/Prospect_Assist_AI_Submission_Deck.pptx
+++ b/Prospect_Assist_AI_Submission_Deck.pptx
@@ -5,23 +5,22 @@
     <p:sldMasterId id="2147483648" r:id="rId1"/>
   </p:sldMasterIdLst>
   <p:notesMasterIdLst>
-    <p:notesMasterId r:id="rId16"/>
+    <p:notesMasterId r:id="rId15"/>
   </p:notesMasterIdLst>
   <p:sldIdLst>
     <p:sldId id="269" r:id="rId2"/>
-    <p:sldId id="256" r:id="rId3"/>
-    <p:sldId id="257" r:id="rId4"/>
-    <p:sldId id="258" r:id="rId5"/>
-    <p:sldId id="259" r:id="rId6"/>
-    <p:sldId id="260" r:id="rId7"/>
-    <p:sldId id="261" r:id="rId8"/>
-    <p:sldId id="262" r:id="rId9"/>
-    <p:sldId id="263" r:id="rId10"/>
-    <p:sldId id="264" r:id="rId11"/>
-    <p:sldId id="265" r:id="rId12"/>
-    <p:sldId id="266" r:id="rId13"/>
-    <p:sldId id="267" r:id="rId14"/>
-    <p:sldId id="268" r:id="rId15"/>
+    <p:sldId id="257" r:id="rId3"/>
+    <p:sldId id="258" r:id="rId4"/>
+    <p:sldId id="259" r:id="rId5"/>
+    <p:sldId id="260" r:id="rId6"/>
+    <p:sldId id="261" r:id="rId7"/>
+    <p:sldId id="262" r:id="rId8"/>
+    <p:sldId id="263" r:id="rId9"/>
+    <p:sldId id="264" r:id="rId10"/>
+    <p:sldId id="265" r:id="rId11"/>
+    <p:sldId id="266" r:id="rId12"/>
+    <p:sldId id="267" r:id="rId13"/>
+    <p:sldId id="268" r:id="rId14"/>
   </p:sldIdLst>
   <p:sldSz cx="12192000" cy="6858000"/>
   <p:notesSz cx="6858000" cy="12192000"/>
@@ -850,90 +849,6 @@
             <a:fld id="{F7021451-1387-4CA6-816F-3879F97B5CBC}" type="slidenum">
               <a:rPr lang="en-US"/>
               <a:t>13</a:t>
-            </a:fld>
-            <a:endParaRPr lang="en-US"/>
-          </a:p>
-        </p:txBody>
-      </p:sp>
-    </p:spTree>
-    <p:extLst>
-      <p:ext uri="{BB962C8B-B14F-4D97-AF65-F5344CB8AC3E}">
-        <p14:creationId xmlns:p14="http://schemas.microsoft.com/office/powerpoint/2010/main" val="1024086991"/>
-      </p:ext>
-    </p:extLst>
-  </p:cSld>
-  <p:clrMapOvr>
-    <a:masterClrMapping/>
-  </p:clrMapOvr>
-</p:notes>
-</file>
-
-<file path=ppt/notesSlides/notesSlide13.xml><?xml version="1.0" encoding="utf-8"?>
-<p:notes xmlns:a="http://schemas.openxmlformats.org/drawingml/2006/main" xmlns:r="http://schemas.openxmlformats.org/officeDocument/2006/relationships" xmlns:p="http://schemas.openxmlformats.org/presentationml/2006/main">
-  <p:cSld>
-    <p:spTree>
-      <p:nvGrpSpPr>
-        <p:cNvPr id="1" name=""/>
-        <p:cNvGrpSpPr/>
-        <p:nvPr/>
-      </p:nvGrpSpPr>
-      <p:grpSpPr>
-        <a:xfrm>
-          <a:off x="0" y="0"/>
-          <a:ext cx="0" cy="0"/>
-          <a:chOff x="0" y="0"/>
-          <a:chExt cx="0" cy="0"/>
-        </a:xfrm>
-      </p:grpSpPr>
-      <p:sp>
-        <p:nvSpPr>
-          <p:cNvPr id="2" name="Slide Image Placeholder 1"/>
-          <p:cNvSpPr>
-            <a:spLocks noGrp="1" noRot="1" noChangeAspect="1"/>
-          </p:cNvSpPr>
-          <p:nvPr>
-            <p:ph type="sldImg"/>
-          </p:nvPr>
-        </p:nvSpPr>
-        <p:spPr/>
-      </p:sp>
-      <p:sp>
-        <p:nvSpPr>
-          <p:cNvPr id="3" name="Notes Placeholder 2"/>
-          <p:cNvSpPr>
-            <a:spLocks noGrp="1"/>
-          </p:cNvSpPr>
-          <p:nvPr>
-            <p:ph type="body" idx="1"/>
-          </p:nvPr>
-        </p:nvSpPr>
-        <p:spPr/>
-        <p:txBody>
-          <a:bodyPr/>
-          <a:lstStyle/>
-          <a:p>
-            <a:endParaRPr lang="en-US" dirty="0"/>
-          </a:p>
-        </p:txBody>
-      </p:sp>
-      <p:sp>
-        <p:nvSpPr>
-          <p:cNvPr id="4" name="Slide Number Placeholder 3"/>
-          <p:cNvSpPr>
-            <a:spLocks noGrp="1"/>
-          </p:cNvSpPr>
-          <p:nvPr>
-            <p:ph type="sldNum" sz="quarter" idx="10"/>
-          </p:nvPr>
-        </p:nvSpPr>
-        <p:spPr/>
-        <p:txBody>
-          <a:bodyPr/>
-          <a:lstStyle/>
-          <a:p>
-            <a:fld id="{F7021451-1387-4CA6-816F-3879F97B5CBC}" type="slidenum">
-              <a:rPr lang="en-US"/>
-              <a:t>14</a:t>
             </a:fld>
             <a:endParaRPr lang="en-US"/>
           </a:p>
@@ -2301,653 +2216,6 @@
 
 <file path=ppt/slides/slide10.xml><?xml version="1.0" encoding="utf-8"?>
 <p:sld xmlns:a="http://schemas.openxmlformats.org/drawingml/2006/main" xmlns:r="http://schemas.openxmlformats.org/officeDocument/2006/relationships" xmlns:p="http://schemas.openxmlformats.org/presentationml/2006/main">
-  <p:cSld name="Slide 9">
-    <p:spTree>
-      <p:nvGrpSpPr>
-        <p:cNvPr id="1" name=""/>
-        <p:cNvGrpSpPr/>
-        <p:nvPr/>
-      </p:nvGrpSpPr>
-      <p:grpSpPr>
-        <a:xfrm>
-          <a:off x="0" y="0"/>
-          <a:ext cx="0" cy="0"/>
-          <a:chOff x="0" y="0"/>
-          <a:chExt cx="0" cy="0"/>
-        </a:xfrm>
-      </p:grpSpPr>
-      <p:sp>
-        <p:nvSpPr>
-          <p:cNvPr id="2" name="Text 0"/>
-          <p:cNvSpPr/>
-          <p:nvPr/>
-        </p:nvSpPr>
-        <p:spPr>
-          <a:xfrm>
-            <a:off x="502920" y="347472"/>
-            <a:ext cx="1417320" cy="292608"/>
-          </a:xfrm>
-          <a:prstGeom prst="roundRect">
-            <a:avLst>
-              <a:gd name="adj" fmla="val 50000"/>
-            </a:avLst>
-          </a:prstGeom>
-          <a:solidFill>
-            <a:srgbClr val="00584C"/>
-          </a:solidFill>
-          <a:ln/>
-        </p:spPr>
-        <p:txBody>
-          <a:bodyPr wrap="square" lIns="0" tIns="0" rIns="0" bIns="0" rtlCol="0" anchor="ctr"/>
-          <a:lstStyle/>
-          <a:p>
-            <a:pPr marL="0" indent="0" algn="ctr">
-              <a:buNone/>
-            </a:pPr>
-            <a:r>
-              <a:rPr lang="en-US" sz="1100" b="1" dirty="0">
-                <a:solidFill>
-                  <a:srgbClr val="FFFFFF"/>
-                </a:solidFill>
-                <a:latin typeface="Calibri" pitchFamily="34" charset="0"/>
-                <a:ea typeface="Calibri" pitchFamily="34" charset="-122"/>
-                <a:cs typeface="Calibri" pitchFamily="34" charset="-120"/>
-              </a:rPr>
-              <a:t>09 · COST</a:t>
-            </a:r>
-            <a:endParaRPr lang="en-US" sz="1100" dirty="0"/>
-          </a:p>
-        </p:txBody>
-      </p:sp>
-      <p:sp>
-        <p:nvSpPr>
-          <p:cNvPr id="3" name="Text 1"/>
-          <p:cNvSpPr/>
-          <p:nvPr/>
-        </p:nvSpPr>
-        <p:spPr>
-          <a:xfrm>
-            <a:off x="502920" y="713232"/>
-            <a:ext cx="11183112" cy="566928"/>
-          </a:xfrm>
-          <a:prstGeom prst="rect">
-            <a:avLst/>
-          </a:prstGeom>
-          <a:noFill/>
-          <a:ln/>
-        </p:spPr>
-        <p:txBody>
-          <a:bodyPr wrap="square" lIns="0" tIns="0" rIns="0" bIns="0" rtlCol="0" anchor="ctr"/>
-          <a:lstStyle/>
-          <a:p>
-            <a:pPr marL="0" indent="0">
-              <a:buNone/>
-            </a:pPr>
-            <a:r>
-              <a:rPr lang="en-US" sz="2800" b="1" dirty="0">
-                <a:solidFill>
-                  <a:srgbClr val="0E201B"/>
-                </a:solidFill>
-                <a:latin typeface="Arial" pitchFamily="34" charset="0"/>
-                <a:ea typeface="Arial" pitchFamily="34" charset="-122"/>
-                <a:cs typeface="Arial" pitchFamily="34" charset="-120"/>
-              </a:rPr>
-              <a:t>Estimated implementation cost (indicative)</a:t>
-            </a:r>
-            <a:endParaRPr lang="en-US" sz="2800" dirty="0"/>
-          </a:p>
-        </p:txBody>
-      </p:sp>
-      <p:sp>
-        <p:nvSpPr>
-          <p:cNvPr id="4" name="Shape 2"/>
-          <p:cNvSpPr/>
-          <p:nvPr/>
-        </p:nvSpPr>
-        <p:spPr>
-          <a:xfrm>
-            <a:off x="502920" y="1600200"/>
-            <a:ext cx="11183112" cy="1389888"/>
-          </a:xfrm>
-          <a:prstGeom prst="roundRect">
-            <a:avLst>
-              <a:gd name="adj" fmla="val 5921"/>
-            </a:avLst>
-          </a:prstGeom>
-          <a:solidFill>
-            <a:srgbClr val="EAF4F1"/>
-          </a:solidFill>
-          <a:ln w="12700">
-            <a:solidFill>
-              <a:srgbClr val="EAF4F1"/>
-            </a:solidFill>
-            <a:prstDash val="solid"/>
-          </a:ln>
-        </p:spPr>
-        <p:txBody>
-          <a:bodyPr/>
-          <a:lstStyle/>
-          <a:p>
-            <a:endParaRPr lang="en-IN"/>
-          </a:p>
-        </p:txBody>
-      </p:sp>
-      <p:sp>
-        <p:nvSpPr>
-          <p:cNvPr id="5" name="Text 3"/>
-          <p:cNvSpPr/>
-          <p:nvPr/>
-        </p:nvSpPr>
-        <p:spPr>
-          <a:xfrm>
-            <a:off x="777240" y="1746504"/>
-            <a:ext cx="3291840" cy="365760"/>
-          </a:xfrm>
-          <a:prstGeom prst="rect">
-            <a:avLst/>
-          </a:prstGeom>
-          <a:noFill/>
-          <a:ln/>
-        </p:spPr>
-        <p:txBody>
-          <a:bodyPr wrap="square" lIns="0" tIns="0" rIns="0" bIns="0" rtlCol="0" anchor="ctr"/>
-          <a:lstStyle/>
-          <a:p>
-            <a:pPr marL="0" indent="0">
-              <a:buNone/>
-            </a:pPr>
-            <a:r>
-              <a:rPr lang="en-US" sz="1400" b="1" dirty="0">
-                <a:solidFill>
-                  <a:srgbClr val="0E201B"/>
-                </a:solidFill>
-                <a:latin typeface="Arial" pitchFamily="34" charset="0"/>
-                <a:ea typeface="Arial" pitchFamily="34" charset="-122"/>
-                <a:cs typeface="Arial" pitchFamily="34" charset="-120"/>
-              </a:rPr>
-              <a:t>Phase 1 — Prototype</a:t>
-            </a:r>
-            <a:endParaRPr lang="en-US" sz="1400" dirty="0"/>
-          </a:p>
-        </p:txBody>
-      </p:sp>
-      <p:sp>
-        <p:nvSpPr>
-          <p:cNvPr id="6" name="Text 4"/>
-          <p:cNvSpPr/>
-          <p:nvPr/>
-        </p:nvSpPr>
-        <p:spPr>
-          <a:xfrm>
-            <a:off x="777240" y="2148840"/>
-            <a:ext cx="3291840" cy="502920"/>
-          </a:xfrm>
-          <a:prstGeom prst="rect">
-            <a:avLst/>
-          </a:prstGeom>
-          <a:noFill/>
-          <a:ln/>
-        </p:spPr>
-        <p:txBody>
-          <a:bodyPr wrap="square" lIns="0" tIns="0" rIns="0" bIns="0" rtlCol="0" anchor="ctr"/>
-          <a:lstStyle/>
-          <a:p>
-            <a:pPr marL="0" indent="0">
-              <a:buNone/>
-            </a:pPr>
-            <a:r>
-              <a:rPr lang="en-US" sz="1900" b="1" dirty="0">
-                <a:solidFill>
-                  <a:srgbClr val="00584C"/>
-                </a:solidFill>
-                <a:latin typeface="Arial" pitchFamily="34" charset="0"/>
-                <a:ea typeface="Arial" pitchFamily="34" charset="-122"/>
-                <a:cs typeface="Arial" pitchFamily="34" charset="-120"/>
-              </a:rPr>
-              <a:t>₹0 infrastructure</a:t>
-            </a:r>
-            <a:endParaRPr lang="en-US" sz="1900" dirty="0"/>
-          </a:p>
-        </p:txBody>
-      </p:sp>
-      <p:sp>
-        <p:nvSpPr>
-          <p:cNvPr id="7" name="Text 5"/>
-          <p:cNvSpPr/>
-          <p:nvPr/>
-        </p:nvSpPr>
-        <p:spPr>
-          <a:xfrm>
-            <a:off x="4343400" y="1746504"/>
-            <a:ext cx="7223760" cy="1097280"/>
-          </a:xfrm>
-          <a:prstGeom prst="rect">
-            <a:avLst/>
-          </a:prstGeom>
-          <a:noFill/>
-          <a:ln/>
-        </p:spPr>
-        <p:txBody>
-          <a:bodyPr wrap="square" lIns="0" tIns="0" rIns="0" bIns="0" rtlCol="0" anchor="ctr"/>
-          <a:lstStyle/>
-          <a:p>
-            <a:pPr marL="0" indent="0">
-              <a:lnSpc>
-                <a:spcPct val="108000"/>
-              </a:lnSpc>
-              <a:buNone/>
-            </a:pPr>
-            <a:r>
-              <a:rPr lang="en-US" sz="1200" dirty="0">
-                <a:solidFill>
-                  <a:srgbClr val="55645F"/>
-                </a:solidFill>
-                <a:latin typeface="Calibri" pitchFamily="34" charset="0"/>
-                <a:ea typeface="Calibri" pitchFamily="34" charset="-122"/>
-                <a:cs typeface="Calibri" pitchFamily="34" charset="-120"/>
-              </a:rPr>
-              <a:t>Runs locally against the synthetic sandbox; no cloud spend, no licensed data. Already built.</a:t>
-            </a:r>
-            <a:endParaRPr lang="en-US" sz="1200" dirty="0"/>
-          </a:p>
-        </p:txBody>
-      </p:sp>
-      <p:sp>
-        <p:nvSpPr>
-          <p:cNvPr id="8" name="Shape 6"/>
-          <p:cNvSpPr/>
-          <p:nvPr/>
-        </p:nvSpPr>
-        <p:spPr>
-          <a:xfrm>
-            <a:off x="502920" y="3136392"/>
-            <a:ext cx="11183112" cy="1389888"/>
-          </a:xfrm>
-          <a:prstGeom prst="roundRect">
-            <a:avLst>
-              <a:gd name="adj" fmla="val 5921"/>
-            </a:avLst>
-          </a:prstGeom>
-          <a:solidFill>
-            <a:srgbClr val="EAF4F1"/>
-          </a:solidFill>
-          <a:ln w="12700">
-            <a:solidFill>
-              <a:srgbClr val="EAF4F1"/>
-            </a:solidFill>
-            <a:prstDash val="solid"/>
-          </a:ln>
-        </p:spPr>
-        <p:txBody>
-          <a:bodyPr/>
-          <a:lstStyle/>
-          <a:p>
-            <a:endParaRPr lang="en-IN"/>
-          </a:p>
-        </p:txBody>
-      </p:sp>
-      <p:sp>
-        <p:nvSpPr>
-          <p:cNvPr id="9" name="Text 7"/>
-          <p:cNvSpPr/>
-          <p:nvPr/>
-        </p:nvSpPr>
-        <p:spPr>
-          <a:xfrm>
-            <a:off x="777240" y="3282696"/>
-            <a:ext cx="3291840" cy="365760"/>
-          </a:xfrm>
-          <a:prstGeom prst="rect">
-            <a:avLst/>
-          </a:prstGeom>
-          <a:noFill/>
-          <a:ln/>
-        </p:spPr>
-        <p:txBody>
-          <a:bodyPr wrap="square" lIns="0" tIns="0" rIns="0" bIns="0" rtlCol="0" anchor="ctr"/>
-          <a:lstStyle/>
-          <a:p>
-            <a:pPr marL="0" indent="0">
-              <a:buNone/>
-            </a:pPr>
-            <a:r>
-              <a:rPr lang="en-US" sz="1400" b="1" dirty="0">
-                <a:solidFill>
-                  <a:srgbClr val="0E201B"/>
-                </a:solidFill>
-                <a:latin typeface="Arial" pitchFamily="34" charset="0"/>
-                <a:ea typeface="Arial" pitchFamily="34" charset="-122"/>
-                <a:cs typeface="Arial" pitchFamily="34" charset="-120"/>
-              </a:rPr>
-              <a:t>Phase 2 — Bank-sandbox pilot</a:t>
-            </a:r>
-            <a:endParaRPr lang="en-US" sz="1400" dirty="0"/>
-          </a:p>
-        </p:txBody>
-      </p:sp>
-      <p:sp>
-        <p:nvSpPr>
-          <p:cNvPr id="10" name="Text 8"/>
-          <p:cNvSpPr/>
-          <p:nvPr/>
-        </p:nvSpPr>
-        <p:spPr>
-          <a:xfrm>
-            <a:off x="777240" y="3685032"/>
-            <a:ext cx="3291840" cy="502920"/>
-          </a:xfrm>
-          <a:prstGeom prst="rect">
-            <a:avLst/>
-          </a:prstGeom>
-          <a:noFill/>
-          <a:ln/>
-        </p:spPr>
-        <p:txBody>
-          <a:bodyPr wrap="square" lIns="0" tIns="0" rIns="0" bIns="0" rtlCol="0" anchor="ctr"/>
-          <a:lstStyle/>
-          <a:p>
-            <a:pPr marL="0" indent="0">
-              <a:buNone/>
-            </a:pPr>
-            <a:r>
-              <a:rPr lang="en-US" sz="1900" b="1" dirty="0">
-                <a:solidFill>
-                  <a:srgbClr val="C77700"/>
-                </a:solidFill>
-                <a:latin typeface="Arial" pitchFamily="34" charset="0"/>
-                <a:ea typeface="Arial" pitchFamily="34" charset="-122"/>
-                <a:cs typeface="Arial" pitchFamily="34" charset="-120"/>
-              </a:rPr>
-              <a:t>≈ ₹40k–60k / month</a:t>
-            </a:r>
-            <a:endParaRPr lang="en-US" sz="1900" dirty="0"/>
-          </a:p>
-        </p:txBody>
-      </p:sp>
-      <p:sp>
-        <p:nvSpPr>
-          <p:cNvPr id="11" name="Text 9"/>
-          <p:cNvSpPr/>
-          <p:nvPr/>
-        </p:nvSpPr>
-        <p:spPr>
-          <a:xfrm>
-            <a:off x="4343400" y="3282696"/>
-            <a:ext cx="7223760" cy="1097280"/>
-          </a:xfrm>
-          <a:prstGeom prst="rect">
-            <a:avLst/>
-          </a:prstGeom>
-          <a:noFill/>
-          <a:ln/>
-        </p:spPr>
-        <p:txBody>
-          <a:bodyPr wrap="square" lIns="0" tIns="0" rIns="0" bIns="0" rtlCol="0" anchor="ctr"/>
-          <a:lstStyle/>
-          <a:p>
-            <a:pPr marL="0" indent="0">
-              <a:lnSpc>
-                <a:spcPct val="108000"/>
-              </a:lnSpc>
-              <a:buNone/>
-            </a:pPr>
-            <a:r>
-              <a:rPr lang="en-US" sz="1200" dirty="0">
-                <a:solidFill>
-                  <a:srgbClr val="55645F"/>
-                </a:solidFill>
-                <a:latin typeface="Calibri" pitchFamily="34" charset="0"/>
-                <a:ea typeface="Calibri" pitchFamily="34" charset="-122"/>
-                <a:cs typeface="Calibri" pitchFamily="34" charset="-120"/>
-              </a:rPr>
-              <a:t>Containerized API + dashboard on AWS (ECS/Fargate, RDS PostgreSQL, ElastiCache, monitoring); IDBI sandbox data via connector swap.</a:t>
-            </a:r>
-            <a:endParaRPr lang="en-US" sz="1200" dirty="0"/>
-          </a:p>
-        </p:txBody>
-      </p:sp>
-      <p:sp>
-        <p:nvSpPr>
-          <p:cNvPr id="12" name="Shape 10"/>
-          <p:cNvSpPr/>
-          <p:nvPr/>
-        </p:nvSpPr>
-        <p:spPr>
-          <a:xfrm>
-            <a:off x="502920" y="4672584"/>
-            <a:ext cx="11183112" cy="1389888"/>
-          </a:xfrm>
-          <a:prstGeom prst="roundRect">
-            <a:avLst>
-              <a:gd name="adj" fmla="val 5921"/>
-            </a:avLst>
-          </a:prstGeom>
-          <a:solidFill>
-            <a:srgbClr val="EAF4F1"/>
-          </a:solidFill>
-          <a:ln w="12700">
-            <a:solidFill>
-              <a:srgbClr val="EAF4F1"/>
-            </a:solidFill>
-            <a:prstDash val="solid"/>
-          </a:ln>
-        </p:spPr>
-        <p:txBody>
-          <a:bodyPr/>
-          <a:lstStyle/>
-          <a:p>
-            <a:endParaRPr lang="en-IN"/>
-          </a:p>
-        </p:txBody>
-      </p:sp>
-      <p:sp>
-        <p:nvSpPr>
-          <p:cNvPr id="13" name="Text 11"/>
-          <p:cNvSpPr/>
-          <p:nvPr/>
-        </p:nvSpPr>
-        <p:spPr>
-          <a:xfrm>
-            <a:off x="777240" y="4818888"/>
-            <a:ext cx="3291840" cy="365760"/>
-          </a:xfrm>
-          <a:prstGeom prst="rect">
-            <a:avLst/>
-          </a:prstGeom>
-          <a:noFill/>
-          <a:ln/>
-        </p:spPr>
-        <p:txBody>
-          <a:bodyPr wrap="square" lIns="0" tIns="0" rIns="0" bIns="0" rtlCol="0" anchor="ctr"/>
-          <a:lstStyle/>
-          <a:p>
-            <a:pPr marL="0" indent="0">
-              <a:buNone/>
-            </a:pPr>
-            <a:r>
-              <a:rPr lang="en-US" sz="1400" b="1" dirty="0">
-                <a:solidFill>
-                  <a:srgbClr val="0E201B"/>
-                </a:solidFill>
-                <a:latin typeface="Arial" pitchFamily="34" charset="0"/>
-                <a:ea typeface="Arial" pitchFamily="34" charset="-122"/>
-                <a:cs typeface="Arial" pitchFamily="34" charset="-120"/>
-              </a:rPr>
-              <a:t>Phase 3 — Production</a:t>
-            </a:r>
-            <a:endParaRPr lang="en-US" sz="1400" dirty="0"/>
-          </a:p>
-        </p:txBody>
-      </p:sp>
-      <p:sp>
-        <p:nvSpPr>
-          <p:cNvPr id="14" name="Text 12"/>
-          <p:cNvSpPr/>
-          <p:nvPr/>
-        </p:nvSpPr>
-        <p:spPr>
-          <a:xfrm>
-            <a:off x="777240" y="5221224"/>
-            <a:ext cx="3291840" cy="502920"/>
-          </a:xfrm>
-          <a:prstGeom prst="rect">
-            <a:avLst/>
-          </a:prstGeom>
-          <a:noFill/>
-          <a:ln/>
-        </p:spPr>
-        <p:txBody>
-          <a:bodyPr wrap="square" lIns="0" tIns="0" rIns="0" bIns="0" rtlCol="0" anchor="ctr"/>
-          <a:lstStyle/>
-          <a:p>
-            <a:pPr marL="0" indent="0">
-              <a:buNone/>
-            </a:pPr>
-            <a:r>
-              <a:rPr lang="en-US" sz="1900" b="1" dirty="0">
-                <a:solidFill>
-                  <a:srgbClr val="2E7D6B"/>
-                </a:solidFill>
-                <a:latin typeface="Arial" pitchFamily="34" charset="0"/>
-                <a:ea typeface="Arial" pitchFamily="34" charset="-122"/>
-                <a:cs typeface="Arial" pitchFamily="34" charset="-120"/>
-              </a:rPr>
-              <a:t>Usage-based</a:t>
-            </a:r>
-            <a:endParaRPr lang="en-US" sz="1900" dirty="0"/>
-          </a:p>
-        </p:txBody>
-      </p:sp>
-      <p:sp>
-        <p:nvSpPr>
-          <p:cNvPr id="15" name="Text 13"/>
-          <p:cNvSpPr/>
-          <p:nvPr/>
-        </p:nvSpPr>
-        <p:spPr>
-          <a:xfrm>
-            <a:off x="4343400" y="4818888"/>
-            <a:ext cx="7223760" cy="1097280"/>
-          </a:xfrm>
-          <a:prstGeom prst="rect">
-            <a:avLst/>
-          </a:prstGeom>
-          <a:noFill/>
-          <a:ln/>
-        </p:spPr>
-        <p:txBody>
-          <a:bodyPr wrap="square" lIns="0" tIns="0" rIns="0" bIns="0" rtlCol="0" anchor="ctr"/>
-          <a:lstStyle/>
-          <a:p>
-            <a:pPr marL="0" indent="0">
-              <a:lnSpc>
-                <a:spcPct val="108000"/>
-              </a:lnSpc>
-              <a:buNone/>
-            </a:pPr>
-            <a:r>
-              <a:rPr lang="en-US" sz="1200" dirty="0">
-                <a:solidFill>
-                  <a:srgbClr val="55645F"/>
-                </a:solidFill>
-                <a:latin typeface="Calibri" pitchFamily="34" charset="0"/>
-                <a:ea typeface="Calibri" pitchFamily="34" charset="-122"/>
-                <a:cs typeface="Calibri" pitchFamily="34" charset="-120"/>
-              </a:rPr>
-              <a:t>Scales with scored-prospect volume; main drivers are model serving, AA/GST/bureau API calls and data retention. Detailed TCO after pilot benchmarking.</a:t>
-            </a:r>
-            <a:endParaRPr lang="en-US" sz="1200" dirty="0"/>
-          </a:p>
-        </p:txBody>
-      </p:sp>
-      <p:sp>
-        <p:nvSpPr>
-          <p:cNvPr id="16" name="Text 14"/>
-          <p:cNvSpPr/>
-          <p:nvPr/>
-        </p:nvSpPr>
-        <p:spPr>
-          <a:xfrm>
-            <a:off x="502920" y="6263640"/>
-            <a:ext cx="11155680" cy="274320"/>
-          </a:xfrm>
-          <a:prstGeom prst="rect">
-            <a:avLst/>
-          </a:prstGeom>
-          <a:noFill/>
-          <a:ln/>
-        </p:spPr>
-        <p:txBody>
-          <a:bodyPr wrap="square" lIns="0" tIns="0" rIns="0" bIns="0" rtlCol="0" anchor="ctr"/>
-          <a:lstStyle/>
-          <a:p>
-            <a:pPr marL="0" indent="0">
-              <a:buNone/>
-            </a:pPr>
-            <a:r>
-              <a:rPr lang="en-US" sz="1050" i="1" dirty="0">
-                <a:solidFill>
-                  <a:srgbClr val="55645F"/>
-                </a:solidFill>
-                <a:latin typeface="Calibri" pitchFamily="34" charset="0"/>
-                <a:ea typeface="Calibri" pitchFamily="34" charset="-122"/>
-                <a:cs typeface="Calibri" pitchFamily="34" charset="-120"/>
-              </a:rPr>
-              <a:t>Figures are indicative estimates for planning only; the prototype's data-source seam keeps re-platforming cost near zero between phases.</a:t>
-            </a:r>
-            <a:endParaRPr lang="en-US" sz="1050" dirty="0"/>
-          </a:p>
-        </p:txBody>
-      </p:sp>
-      <p:sp>
-        <p:nvSpPr>
-          <p:cNvPr id="17" name="Text 15"/>
-          <p:cNvSpPr/>
-          <p:nvPr/>
-        </p:nvSpPr>
-        <p:spPr>
-          <a:xfrm>
-            <a:off x="502920" y="6473952"/>
-            <a:ext cx="5486400" cy="274320"/>
-          </a:xfrm>
-          <a:prstGeom prst="rect">
-            <a:avLst/>
-          </a:prstGeom>
-          <a:noFill/>
-          <a:ln/>
-        </p:spPr>
-        <p:txBody>
-          <a:bodyPr wrap="square" lIns="0" tIns="0" rIns="0" bIns="0" rtlCol="0" anchor="ctr"/>
-          <a:lstStyle/>
-          <a:p>
-            <a:pPr marL="0" indent="0">
-              <a:buNone/>
-            </a:pPr>
-            <a:r>
-              <a:rPr lang="en-US" sz="900" dirty="0">
-                <a:solidFill>
-                  <a:srgbClr val="55645F"/>
-                </a:solidFill>
-                <a:latin typeface="Calibri" pitchFamily="34" charset="0"/>
-                <a:ea typeface="Calibri" pitchFamily="34" charset="-122"/>
-                <a:cs typeface="Calibri" pitchFamily="34" charset="-120"/>
-              </a:rPr>
-              <a:t>Prospect Assist AI · IDBI Innovate 2026 · Track 2</a:t>
-            </a:r>
-            <a:endParaRPr lang="en-US" sz="900" dirty="0"/>
-          </a:p>
-        </p:txBody>
-      </p:sp>
-    </p:spTree>
-  </p:cSld>
-  <p:clrMapOvr>
-    <a:masterClrMapping/>
-  </p:clrMapOvr>
-</p:sld>
-</file>
-
-<file path=ppt/slides/slide11.xml><?xml version="1.0" encoding="utf-8"?>
-<p:sld xmlns:a="http://schemas.openxmlformats.org/drawingml/2006/main" xmlns:r="http://schemas.openxmlformats.org/officeDocument/2006/relationships" xmlns:p="http://schemas.openxmlformats.org/presentationml/2006/main">
   <p:cSld name="Slide 10">
     <p:spTree>
       <p:nvGrpSpPr>
@@ -3232,7 +2500,7 @@
 </p:sld>
 </file>
 
-<file path=ppt/slides/slide12.xml><?xml version="1.0" encoding="utf-8"?>
+<file path=ppt/slides/slide11.xml><?xml version="1.0" encoding="utf-8"?>
 <p:sld xmlns:a="http://schemas.openxmlformats.org/drawingml/2006/main" xmlns:r="http://schemas.openxmlformats.org/officeDocument/2006/relationships" xmlns:p="http://schemas.openxmlformats.org/presentationml/2006/main">
   <p:cSld name="Slide 11">
     <p:spTree>
@@ -5043,7 +4311,7 @@
 </p:sld>
 </file>
 
-<file path=ppt/slides/slide13.xml><?xml version="1.0" encoding="utf-8"?>
+<file path=ppt/slides/slide12.xml><?xml version="1.0" encoding="utf-8"?>
 <p:sld xmlns:a="http://schemas.openxmlformats.org/drawingml/2006/main" xmlns:r="http://schemas.openxmlformats.org/officeDocument/2006/relationships" xmlns:p="http://schemas.openxmlformats.org/presentationml/2006/main">
   <p:cSld name="Slide 12">
     <p:spTree>
@@ -5738,7 +5006,7 @@
 </p:sld>
 </file>
 
-<file path=ppt/slides/slide14.xml><?xml version="1.0" encoding="utf-8"?>
+<file path=ppt/slides/slide13.xml><?xml version="1.0" encoding="utf-8"?>
 <p:sld xmlns:a="http://schemas.openxmlformats.org/drawingml/2006/main" xmlns:r="http://schemas.openxmlformats.org/officeDocument/2006/relationships" xmlns:p="http://schemas.openxmlformats.org/presentationml/2006/main">
   <p:cSld name="Slide 13">
     <p:bg>
@@ -6187,472 +5455,6 @@
 
 <file path=ppt/slides/slide2.xml><?xml version="1.0" encoding="utf-8"?>
 <p:sld xmlns:a="http://schemas.openxmlformats.org/drawingml/2006/main" xmlns:r="http://schemas.openxmlformats.org/officeDocument/2006/relationships" xmlns:p="http://schemas.openxmlformats.org/presentationml/2006/main">
-  <p:cSld name="Slide 1">
-    <p:bg>
-      <p:bgPr>
-        <a:solidFill>
-          <a:srgbClr val="00584C"/>
-        </a:solidFill>
-        <a:effectLst/>
-      </p:bgPr>
-    </p:bg>
-    <p:spTree>
-      <p:nvGrpSpPr>
-        <p:cNvPr id="1" name=""/>
-        <p:cNvGrpSpPr/>
-        <p:nvPr/>
-      </p:nvGrpSpPr>
-      <p:grpSpPr>
-        <a:xfrm>
-          <a:off x="0" y="0"/>
-          <a:ext cx="0" cy="0"/>
-          <a:chOff x="0" y="0"/>
-          <a:chExt cx="0" cy="0"/>
-        </a:xfrm>
-      </p:grpSpPr>
-      <p:sp>
-        <p:nvSpPr>
-          <p:cNvPr id="2" name="Text 0"/>
-          <p:cNvSpPr/>
-          <p:nvPr/>
-        </p:nvSpPr>
-        <p:spPr>
-          <a:xfrm>
-            <a:off x="502920" y="960120"/>
-            <a:ext cx="11155680" cy="868680"/>
-          </a:xfrm>
-          <a:prstGeom prst="rect">
-            <a:avLst/>
-          </a:prstGeom>
-          <a:noFill/>
-          <a:ln/>
-        </p:spPr>
-        <p:txBody>
-          <a:bodyPr wrap="square" lIns="0" tIns="0" rIns="0" bIns="0" rtlCol="0" anchor="ctr"/>
-          <a:lstStyle/>
-          <a:p>
-            <a:pPr marL="0" indent="0">
-              <a:buNone/>
-            </a:pPr>
-            <a:r>
-              <a:rPr lang="en-US" sz="4800" b="1" dirty="0">
-                <a:solidFill>
-                  <a:srgbClr val="FFFFFF"/>
-                </a:solidFill>
-                <a:latin typeface="Arial" pitchFamily="34" charset="0"/>
-                <a:ea typeface="Arial" pitchFamily="34" charset="-122"/>
-                <a:cs typeface="Arial" pitchFamily="34" charset="-120"/>
-              </a:rPr>
-              <a:t>Prospect Assist AI</a:t>
-            </a:r>
-            <a:endParaRPr lang="en-US" sz="4800" dirty="0"/>
-          </a:p>
-        </p:txBody>
-      </p:sp>
-      <p:sp>
-        <p:nvSpPr>
-          <p:cNvPr id="3" name="Text 1"/>
-          <p:cNvSpPr/>
-          <p:nvPr/>
-        </p:nvSpPr>
-        <p:spPr>
-          <a:xfrm>
-            <a:off x="502920" y="1828800"/>
-            <a:ext cx="10424160" cy="411480"/>
-          </a:xfrm>
-          <a:prstGeom prst="rect">
-            <a:avLst/>
-          </a:prstGeom>
-          <a:noFill/>
-          <a:ln/>
-        </p:spPr>
-        <p:txBody>
-          <a:bodyPr wrap="square" lIns="0" tIns="0" rIns="0" bIns="0" rtlCol="0" anchor="ctr"/>
-          <a:lstStyle/>
-          <a:p>
-            <a:pPr marL="0" indent="0">
-              <a:buNone/>
-            </a:pPr>
-            <a:r>
-              <a:rPr lang="en-US" sz="1700" dirty="0">
-                <a:solidFill>
-                  <a:srgbClr val="CDE8E0"/>
-                </a:solidFill>
-                <a:latin typeface="Calibri" pitchFamily="34" charset="0"/>
-                <a:ea typeface="Calibri" pitchFamily="34" charset="-122"/>
-                <a:cs typeface="Calibri" pitchFamily="34" charset="-120"/>
-              </a:rPr>
-              <a:t>Behavior-driven lead generation &amp; underwriting support for IDBI retail lending</a:t>
-            </a:r>
-            <a:endParaRPr lang="en-US" sz="1700" dirty="0"/>
-          </a:p>
-        </p:txBody>
-      </p:sp>
-      <p:sp>
-        <p:nvSpPr>
-          <p:cNvPr id="4" name="Text 2"/>
-          <p:cNvSpPr/>
-          <p:nvPr/>
-        </p:nvSpPr>
-        <p:spPr>
-          <a:xfrm>
-            <a:off x="502920" y="2249424"/>
-            <a:ext cx="10424160" cy="365760"/>
-          </a:xfrm>
-          <a:prstGeom prst="rect">
-            <a:avLst/>
-          </a:prstGeom>
-          <a:noFill/>
-          <a:ln/>
-        </p:spPr>
-        <p:txBody>
-          <a:bodyPr wrap="square" lIns="0" tIns="0" rIns="0" bIns="0" rtlCol="0" anchor="ctr"/>
-          <a:lstStyle/>
-          <a:p>
-            <a:pPr marL="0" indent="0">
-              <a:buNone/>
-            </a:pPr>
-            <a:r>
-              <a:rPr lang="en-US" sz="1300" i="1" dirty="0">
-                <a:solidFill>
-                  <a:srgbClr val="9EC9BE"/>
-                </a:solidFill>
-                <a:latin typeface="Calibri" pitchFamily="34" charset="0"/>
-                <a:ea typeface="Calibri" pitchFamily="34" charset="-122"/>
-                <a:cs typeface="Calibri" pitchFamily="34" charset="-120"/>
-              </a:rPr>
-              <a:t>IDBI Innovate 2026 · Track 2 · Prototype Submission</a:t>
-            </a:r>
-            <a:endParaRPr lang="en-US" sz="1300" dirty="0"/>
-          </a:p>
-        </p:txBody>
-      </p:sp>
-      <p:sp>
-        <p:nvSpPr>
-          <p:cNvPr id="5" name="Shape 3"/>
-          <p:cNvSpPr/>
-          <p:nvPr/>
-        </p:nvSpPr>
-        <p:spPr>
-          <a:xfrm>
-            <a:off x="502920" y="3017520"/>
-            <a:ext cx="11183112" cy="2926080"/>
-          </a:xfrm>
-          <a:prstGeom prst="roundRect">
-            <a:avLst>
-              <a:gd name="adj" fmla="val 2813"/>
-            </a:avLst>
-          </a:prstGeom>
-          <a:solidFill>
-            <a:srgbClr val="FFFFFF"/>
-          </a:solidFill>
-          <a:ln w="12700">
-            <a:solidFill>
-              <a:srgbClr val="FFFFFF"/>
-            </a:solidFill>
-            <a:prstDash val="solid"/>
-          </a:ln>
-        </p:spPr>
-        <p:txBody>
-          <a:bodyPr/>
-          <a:lstStyle/>
-          <a:p>
-            <a:endParaRPr lang="en-IN" dirty="0"/>
-          </a:p>
-        </p:txBody>
-      </p:sp>
-      <p:sp>
-        <p:nvSpPr>
-          <p:cNvPr id="6" name="Text 4"/>
-          <p:cNvSpPr/>
-          <p:nvPr/>
-        </p:nvSpPr>
-        <p:spPr>
-          <a:xfrm>
-            <a:off x="868680" y="3246120"/>
-            <a:ext cx="5486400" cy="365760"/>
-          </a:xfrm>
-          <a:prstGeom prst="rect">
-            <a:avLst/>
-          </a:prstGeom>
-          <a:noFill/>
-          <a:ln/>
-        </p:spPr>
-        <p:txBody>
-          <a:bodyPr wrap="square" lIns="0" tIns="0" rIns="0" bIns="0" rtlCol="0" anchor="ctr"/>
-          <a:lstStyle/>
-          <a:p>
-            <a:pPr marL="0" indent="0">
-              <a:buNone/>
-            </a:pPr>
-            <a:r>
-              <a:rPr lang="en-US" sz="1600" b="1" dirty="0">
-                <a:solidFill>
-                  <a:srgbClr val="0E201B"/>
-                </a:solidFill>
-                <a:latin typeface="Arial" pitchFamily="34" charset="0"/>
-                <a:ea typeface="Arial" pitchFamily="34" charset="-122"/>
-                <a:cs typeface="Arial" pitchFamily="34" charset="-120"/>
-              </a:rPr>
-              <a:t>Team Details</a:t>
-            </a:r>
-            <a:endParaRPr lang="en-US" sz="1600" dirty="0"/>
-          </a:p>
-        </p:txBody>
-      </p:sp>
-      <p:sp>
-        <p:nvSpPr>
-          <p:cNvPr id="7" name="Text 5"/>
-          <p:cNvSpPr/>
-          <p:nvPr/>
-        </p:nvSpPr>
-        <p:spPr>
-          <a:xfrm>
-            <a:off x="868680" y="3703320"/>
-            <a:ext cx="2651760" cy="685800"/>
-          </a:xfrm>
-          <a:prstGeom prst="rect">
-            <a:avLst/>
-          </a:prstGeom>
-          <a:noFill/>
-          <a:ln/>
-        </p:spPr>
-        <p:txBody>
-          <a:bodyPr wrap="square" lIns="0" tIns="0" rIns="0" bIns="0" rtlCol="0" anchor="t"/>
-          <a:lstStyle/>
-          <a:p>
-            <a:pPr marL="0" indent="0">
-              <a:buNone/>
-            </a:pPr>
-            <a:r>
-              <a:rPr lang="en-US" sz="1350" b="1" dirty="0">
-                <a:solidFill>
-                  <a:srgbClr val="00584C"/>
-                </a:solidFill>
-                <a:latin typeface="Calibri" pitchFamily="34" charset="0"/>
-                <a:ea typeface="Calibri" pitchFamily="34" charset="-122"/>
-                <a:cs typeface="Calibri" pitchFamily="34" charset="-120"/>
-              </a:rPr>
-              <a:t>a.  Team name</a:t>
-            </a:r>
-            <a:endParaRPr lang="en-US" sz="1350" dirty="0"/>
-          </a:p>
-        </p:txBody>
-      </p:sp>
-      <p:sp>
-        <p:nvSpPr>
-          <p:cNvPr id="8" name="Text 6"/>
-          <p:cNvSpPr/>
-          <p:nvPr/>
-        </p:nvSpPr>
-        <p:spPr>
-          <a:xfrm>
-            <a:off x="3657600" y="3703320"/>
-            <a:ext cx="7680960" cy="685800"/>
-          </a:xfrm>
-          <a:prstGeom prst="rect">
-            <a:avLst/>
-          </a:prstGeom>
-          <a:noFill/>
-          <a:ln/>
-        </p:spPr>
-        <p:txBody>
-          <a:bodyPr wrap="square" lIns="0" tIns="0" rIns="0" bIns="0" rtlCol="0" anchor="t"/>
-          <a:lstStyle/>
-          <a:p>
-            <a:pPr marL="0" indent="0">
-              <a:lnSpc>
-                <a:spcPct val="105000"/>
-              </a:lnSpc>
-              <a:buNone/>
-            </a:pPr>
-            <a:r>
-              <a:rPr lang="en-US" sz="1250" dirty="0">
-                <a:solidFill>
-                  <a:srgbClr val="0E201B"/>
-                </a:solidFill>
-                <a:latin typeface="Calibri" pitchFamily="34" charset="0"/>
-                <a:ea typeface="Calibri" pitchFamily="34" charset="-122"/>
-                <a:cs typeface="Calibri" pitchFamily="34" charset="-120"/>
-              </a:rPr>
-              <a:t>____________________________</a:t>
-            </a:r>
-            <a:endParaRPr lang="en-US" sz="1250" dirty="0"/>
-          </a:p>
-        </p:txBody>
-      </p:sp>
-      <p:sp>
-        <p:nvSpPr>
-          <p:cNvPr id="9" name="Text 7"/>
-          <p:cNvSpPr/>
-          <p:nvPr/>
-        </p:nvSpPr>
-        <p:spPr>
-          <a:xfrm>
-            <a:off x="868680" y="4416552"/>
-            <a:ext cx="2651760" cy="685800"/>
-          </a:xfrm>
-          <a:prstGeom prst="rect">
-            <a:avLst/>
-          </a:prstGeom>
-          <a:noFill/>
-          <a:ln/>
-        </p:spPr>
-        <p:txBody>
-          <a:bodyPr wrap="square" lIns="0" tIns="0" rIns="0" bIns="0" rtlCol="0" anchor="t"/>
-          <a:lstStyle/>
-          <a:p>
-            <a:pPr marL="0" indent="0">
-              <a:buNone/>
-            </a:pPr>
-            <a:r>
-              <a:rPr lang="en-US" sz="1350" b="1" dirty="0">
-                <a:solidFill>
-                  <a:srgbClr val="00584C"/>
-                </a:solidFill>
-                <a:latin typeface="Calibri" pitchFamily="34" charset="0"/>
-                <a:ea typeface="Calibri" pitchFamily="34" charset="-122"/>
-                <a:cs typeface="Calibri" pitchFamily="34" charset="-120"/>
-              </a:rPr>
-              <a:t>b.  Team leader name</a:t>
-            </a:r>
-            <a:endParaRPr lang="en-US" sz="1350" dirty="0"/>
-          </a:p>
-        </p:txBody>
-      </p:sp>
-      <p:sp>
-        <p:nvSpPr>
-          <p:cNvPr id="10" name="Text 8"/>
-          <p:cNvSpPr/>
-          <p:nvPr/>
-        </p:nvSpPr>
-        <p:spPr>
-          <a:xfrm>
-            <a:off x="3657600" y="4416552"/>
-            <a:ext cx="7680960" cy="685800"/>
-          </a:xfrm>
-          <a:prstGeom prst="rect">
-            <a:avLst/>
-          </a:prstGeom>
-          <a:noFill/>
-          <a:ln/>
-        </p:spPr>
-        <p:txBody>
-          <a:bodyPr wrap="square" lIns="0" tIns="0" rIns="0" bIns="0" rtlCol="0" anchor="t"/>
-          <a:lstStyle/>
-          <a:p>
-            <a:pPr marL="0" indent="0">
-              <a:lnSpc>
-                <a:spcPct val="105000"/>
-              </a:lnSpc>
-              <a:buNone/>
-            </a:pPr>
-            <a:r>
-              <a:rPr lang="en-US" sz="1250" dirty="0">
-                <a:solidFill>
-                  <a:srgbClr val="0E201B"/>
-                </a:solidFill>
-                <a:latin typeface="Calibri" pitchFamily="34" charset="0"/>
-                <a:ea typeface="Calibri" pitchFamily="34" charset="-122"/>
-                <a:cs typeface="Calibri" pitchFamily="34" charset="-120"/>
-              </a:rPr>
-              <a:t>____________________________</a:t>
-            </a:r>
-            <a:endParaRPr lang="en-US" sz="1250" dirty="0"/>
-          </a:p>
-        </p:txBody>
-      </p:sp>
-      <p:sp>
-        <p:nvSpPr>
-          <p:cNvPr id="11" name="Text 9"/>
-          <p:cNvSpPr/>
-          <p:nvPr/>
-        </p:nvSpPr>
-        <p:spPr>
-          <a:xfrm>
-            <a:off x="868680" y="5129784"/>
-            <a:ext cx="2651760" cy="685800"/>
-          </a:xfrm>
-          <a:prstGeom prst="rect">
-            <a:avLst/>
-          </a:prstGeom>
-          <a:noFill/>
-          <a:ln/>
-        </p:spPr>
-        <p:txBody>
-          <a:bodyPr wrap="square" lIns="0" tIns="0" rIns="0" bIns="0" rtlCol="0" anchor="t"/>
-          <a:lstStyle/>
-          <a:p>
-            <a:pPr marL="0" indent="0">
-              <a:buNone/>
-            </a:pPr>
-            <a:r>
-              <a:rPr lang="en-US" sz="1350" b="1" dirty="0">
-                <a:solidFill>
-                  <a:srgbClr val="00584C"/>
-                </a:solidFill>
-                <a:latin typeface="Calibri" pitchFamily="34" charset="0"/>
-                <a:ea typeface="Calibri" pitchFamily="34" charset="-122"/>
-                <a:cs typeface="Calibri" pitchFamily="34" charset="-120"/>
-              </a:rPr>
-              <a:t>c.  Problem statement</a:t>
-            </a:r>
-            <a:endParaRPr lang="en-US" sz="1350" dirty="0"/>
-          </a:p>
-        </p:txBody>
-      </p:sp>
-      <p:sp>
-        <p:nvSpPr>
-          <p:cNvPr id="12" name="Text 10"/>
-          <p:cNvSpPr/>
-          <p:nvPr/>
-        </p:nvSpPr>
-        <p:spPr>
-          <a:xfrm>
-            <a:off x="3657600" y="5129784"/>
-            <a:ext cx="7680960" cy="685800"/>
-          </a:xfrm>
-          <a:prstGeom prst="rect">
-            <a:avLst/>
-          </a:prstGeom>
-          <a:noFill/>
-          <a:ln/>
-        </p:spPr>
-        <p:txBody>
-          <a:bodyPr wrap="square" lIns="0" tIns="0" rIns="0" bIns="0" rtlCol="0" anchor="t"/>
-          <a:lstStyle/>
-          <a:p>
-            <a:pPr marL="0" indent="0">
-              <a:lnSpc>
-                <a:spcPct val="105000"/>
-              </a:lnSpc>
-              <a:buNone/>
-            </a:pPr>
-            <a:r>
-              <a:rPr lang="en-US" sz="1250" dirty="0">
-                <a:solidFill>
-                  <a:srgbClr val="0E201B"/>
-                </a:solidFill>
-                <a:latin typeface="Calibri" pitchFamily="34" charset="0"/>
-                <a:ea typeface="Calibri" pitchFamily="34" charset="-122"/>
-                <a:cs typeface="Calibri" pitchFamily="34" charset="-120"/>
-              </a:rPr>
-              <a:t>Track 2 — Prospect Assist AI: data-driven identification of eligible, repayment-capable, genuinely interested retail-loan prospects from transaction &amp; behavioral insights (Personal · Home · Mortgage/LAP · Auto)</a:t>
-            </a:r>
-            <a:endParaRPr lang="en-US" sz="1250" dirty="0"/>
-          </a:p>
-        </p:txBody>
-      </p:sp>
-    </p:spTree>
-  </p:cSld>
-  <p:clrMapOvr>
-    <a:masterClrMapping/>
-  </p:clrMapOvr>
-</p:sld>
-</file>
-
-<file path=ppt/slides/slide3.xml><?xml version="1.0" encoding="utf-8"?>
-<p:sld xmlns:a="http://schemas.openxmlformats.org/drawingml/2006/main" xmlns:r="http://schemas.openxmlformats.org/officeDocument/2006/relationships" xmlns:p="http://schemas.openxmlformats.org/presentationml/2006/main">
   <p:cSld name="Slide 2">
     <p:spTree>
       <p:nvGrpSpPr>
@@ -7294,7 +6096,7 @@
 </p:sld>
 </file>
 
-<file path=ppt/slides/slide4.xml><?xml version="1.0" encoding="utf-8"?>
+<file path=ppt/slides/slide3.xml><?xml version="1.0" encoding="utf-8"?>
 <p:sld xmlns:a="http://schemas.openxmlformats.org/drawingml/2006/main" xmlns:r="http://schemas.openxmlformats.org/officeDocument/2006/relationships" xmlns:p="http://schemas.openxmlformats.org/presentationml/2006/main">
   <p:cSld name="Slide 3">
     <p:spTree>
@@ -8013,7 +6815,7 @@
 </p:sld>
 </file>
 
-<file path=ppt/slides/slide5.xml><?xml version="1.0" encoding="utf-8"?>
+<file path=ppt/slides/slide4.xml><?xml version="1.0" encoding="utf-8"?>
 <p:sld xmlns:a="http://schemas.openxmlformats.org/drawingml/2006/main" xmlns:r="http://schemas.openxmlformats.org/officeDocument/2006/relationships" xmlns:p="http://schemas.openxmlformats.org/presentationml/2006/main">
   <p:cSld name="Slide 4">
     <p:spTree>
@@ -9079,7 +7881,7 @@
 </p:sld>
 </file>
 
-<file path=ppt/slides/slide6.xml><?xml version="1.0" encoding="utf-8"?>
+<file path=ppt/slides/slide5.xml><?xml version="1.0" encoding="utf-8"?>
 <p:sld xmlns:a="http://schemas.openxmlformats.org/drawingml/2006/main" xmlns:r="http://schemas.openxmlformats.org/officeDocument/2006/relationships" xmlns:p="http://schemas.openxmlformats.org/presentationml/2006/main">
   <p:cSld name="Slide 5">
     <p:spTree>
@@ -10384,7 +9186,7 @@
 </p:sld>
 </file>
 
-<file path=ppt/slides/slide7.xml><?xml version="1.0" encoding="utf-8"?>
+<file path=ppt/slides/slide6.xml><?xml version="1.0" encoding="utf-8"?>
 <p:sld xmlns:a="http://schemas.openxmlformats.org/drawingml/2006/main" xmlns:r="http://schemas.openxmlformats.org/officeDocument/2006/relationships" xmlns:p="http://schemas.openxmlformats.org/presentationml/2006/main">
   <p:cSld name="Slide 6">
     <p:spTree>
@@ -10561,7 +9363,7 @@
 </p:sld>
 </file>
 
-<file path=ppt/slides/slide8.xml><?xml version="1.0" encoding="utf-8"?>
+<file path=ppt/slides/slide7.xml><?xml version="1.0" encoding="utf-8"?>
 <p:sld xmlns:a="http://schemas.openxmlformats.org/drawingml/2006/main" xmlns:r="http://schemas.openxmlformats.org/officeDocument/2006/relationships" xmlns:p="http://schemas.openxmlformats.org/presentationml/2006/main">
   <p:cSld name="Slide 7">
     <p:spTree>
@@ -11611,7 +10413,7 @@
 </p:sld>
 </file>
 
-<file path=ppt/slides/slide9.xml><?xml version="1.0" encoding="utf-8"?>
+<file path=ppt/slides/slide8.xml><?xml version="1.0" encoding="utf-8"?>
 <p:sld xmlns:a="http://schemas.openxmlformats.org/drawingml/2006/main" xmlns:r="http://schemas.openxmlformats.org/officeDocument/2006/relationships" xmlns:p="http://schemas.openxmlformats.org/presentationml/2006/main">
   <p:cSld name="Slide 8">
     <p:spTree>
@@ -12176,6 +10978,1465 @@
               <a:t>Prospect Assist AI · IDBI Innovate 2026 · Track 2</a:t>
             </a:r>
             <a:endParaRPr lang="en-US" sz="900" dirty="0"/>
+          </a:p>
+        </p:txBody>
+      </p:sp>
+    </p:spTree>
+  </p:cSld>
+  <p:clrMapOvr>
+    <a:masterClrMapping/>
+  </p:clrMapOvr>
+</p:sld>
+</file>
+
+<file path=ppt/slides/slide9.xml><?xml version="1.0" encoding="utf-8"?>
+<p:sld xmlns:a="http://schemas.openxmlformats.org/drawingml/2006/main" xmlns:r="http://schemas.openxmlformats.org/officeDocument/2006/relationships" xmlns:p="http://schemas.openxmlformats.org/presentationml/2006/main">
+  <p:cSld name="Slide 9">
+    <p:spTree>
+      <p:nvGrpSpPr>
+        <p:cNvPr id="1" name=""/>
+        <p:cNvGrpSpPr/>
+        <p:nvPr/>
+      </p:nvGrpSpPr>
+      <p:grpSpPr>
+        <a:xfrm>
+          <a:off x="0" y="0"/>
+          <a:ext cx="0" cy="0"/>
+          <a:chOff x="0" y="0"/>
+          <a:chExt cx="0" cy="0"/>
+        </a:xfrm>
+      </p:grpSpPr>
+      <p:sp>
+        <p:nvSpPr>
+          <p:cNvPr id="2" name="Rounded Rectangle 1"/>
+          <p:cNvSpPr/>
+          <p:nvPr/>
+        </p:nvSpPr>
+        <p:spPr>
+          <a:xfrm>
+            <a:off x="502920" y="347472"/>
+            <a:ext cx="1417320" cy="292608"/>
+          </a:xfrm>
+          <a:prstGeom prst="roundRect">
+            <a:avLst>
+              <a:gd name="adj" fmla="val 50000"/>
+            </a:avLst>
+          </a:prstGeom>
+          <a:solidFill>
+            <a:srgbClr val="00584C"/>
+          </a:solidFill>
+          <a:ln>
+            <a:noFill/>
+          </a:ln>
+        </p:spPr>
+        <p:style>
+          <a:lnRef idx="1">
+            <a:schemeClr val="accent1"/>
+          </a:lnRef>
+          <a:fillRef idx="3">
+            <a:schemeClr val="accent1"/>
+          </a:fillRef>
+          <a:effectRef idx="2">
+            <a:schemeClr val="accent1"/>
+          </a:effectRef>
+          <a:fontRef idx="minor">
+            <a:schemeClr val="lt1"/>
+          </a:fontRef>
+        </p:style>
+        <p:txBody>
+          <a:bodyPr rtlCol="0" anchor="ctr" lIns="0" rIns="0" tIns="0" bIns="0"/>
+          <a:lstStyle/>
+          <a:p>
+            <a:pPr algn="ctr"/>
+            <a:r>
+              <a:rPr sz="1100" b="1">
+                <a:solidFill>
+                  <a:srgbClr val="FFFFFF"/>
+                </a:solidFill>
+                <a:latin typeface="Calibri"/>
+              </a:rPr>
+              <a:t>09 · COST</a:t>
+            </a:r>
+          </a:p>
+        </p:txBody>
+      </p:sp>
+      <p:sp>
+        <p:nvSpPr>
+          <p:cNvPr id="3" name="TextBox 2"/>
+          <p:cNvSpPr txBox="1"/>
+          <p:nvPr/>
+        </p:nvSpPr>
+        <p:spPr>
+          <a:xfrm>
+            <a:off x="502920" y="713232"/>
+            <a:ext cx="11155680" cy="566928"/>
+          </a:xfrm>
+          <a:prstGeom prst="rect">
+            <a:avLst/>
+          </a:prstGeom>
+          <a:noFill/>
+        </p:spPr>
+        <p:txBody>
+          <a:bodyPr wrap="square" anchor="t" lIns="0" rIns="0" tIns="0" bIns="0">
+            <a:spAutoFit/>
+          </a:bodyPr>
+          <a:lstStyle/>
+          <a:p>
+            <a:pPr algn="l">
+              <a:lnSpc>
+                <a:spcPct val="105000"/>
+              </a:lnSpc>
+            </a:pPr>
+            <a:r>
+              <a:rPr sz="2800" b="1" i="0">
+                <a:solidFill>
+                  <a:srgbClr val="0E201B"/>
+                </a:solidFill>
+                <a:latin typeface="Arial"/>
+              </a:rPr>
+              <a:t>Estimated implementation cost</a:t>
+            </a:r>
+          </a:p>
+        </p:txBody>
+      </p:sp>
+      <p:sp>
+        <p:nvSpPr>
+          <p:cNvPr id="4" name="TextBox 3"/>
+          <p:cNvSpPr txBox="1"/>
+          <p:nvPr/>
+        </p:nvSpPr>
+        <p:spPr>
+          <a:xfrm>
+            <a:off x="502920" y="1298448"/>
+            <a:ext cx="11155680" cy="320040"/>
+          </a:xfrm>
+          <a:prstGeom prst="rect">
+            <a:avLst/>
+          </a:prstGeom>
+          <a:noFill/>
+        </p:spPr>
+        <p:txBody>
+          <a:bodyPr wrap="square" anchor="t" lIns="0" rIns="0" tIns="0" bIns="0">
+            <a:spAutoFit/>
+          </a:bodyPr>
+          <a:lstStyle/>
+          <a:p>
+            <a:pPr algn="l">
+              <a:lnSpc>
+                <a:spcPct val="105000"/>
+              </a:lnSpc>
+            </a:pPr>
+            <a:r>
+              <a:rPr sz="1250" b="0" i="1">
+                <a:solidFill>
+                  <a:srgbClr val="55645F"/>
+                </a:solidFill>
+                <a:latin typeface="Calibri"/>
+              </a:rPr>
+              <a:t>Pilot scenario — 100K customers, 12 months of transaction data (AWS, indicative)</a:t>
+            </a:r>
+          </a:p>
+        </p:txBody>
+      </p:sp>
+      <p:graphicFrame>
+        <p:nvGraphicFramePr>
+          <p:cNvPr id="5" name="Table 4"/>
+          <p:cNvGraphicFramePr>
+            <a:graphicFrameLocks noGrp="1"/>
+          </p:cNvGraphicFramePr>
+          <p:nvPr/>
+        </p:nvGraphicFramePr>
+        <p:xfrm>
+          <a:off x="502920" y="1755648"/>
+          <a:ext cx="6309360" cy="4425696"/>
+        </p:xfrm>
+        <a:graphic>
+          <a:graphicData uri="http://schemas.openxmlformats.org/drawingml/2006/table">
+            <a:tbl>
+              <a:tblPr firstRow="1" bandRow="0">
+                <a:tableStyleId>{5940675A-B579-460E-94D1-54222C63F5DA}</a:tableStyleId>
+              </a:tblPr>
+              <a:tblGrid>
+                <a:gridCol w="2514600"/>
+                <a:gridCol w="1508760"/>
+                <a:gridCol w="2286000"/>
+              </a:tblGrid>
+              <a:tr h="402336">
+                <a:tc>
+                  <a:txBody>
+                    <a:bodyPr wrap="square"/>
+                    <a:lstStyle/>
+                    <a:p>
+                      <a:pPr algn="l"/>
+                      <a:r>
+                        <a:rPr sz="1100" b="1" i="0">
+                          <a:solidFill>
+                            <a:srgbClr val="FFFFFF"/>
+                          </a:solidFill>
+                          <a:latin typeface="Calibri"/>
+                        </a:rPr>
+                        <a:t>Component</a:t>
+                      </a:r>
+                    </a:p>
+                  </a:txBody>
+                  <a:tcPr anchor="ctr" marL="73152" marR="73152" marT="18288" marB="18288">
+                    <a:solidFill>
+                      <a:srgbClr val="00584C"/>
+                    </a:solidFill>
+                  </a:tcPr>
+                </a:tc>
+                <a:tc>
+                  <a:txBody>
+                    <a:bodyPr wrap="square"/>
+                    <a:lstStyle/>
+                    <a:p>
+                      <a:pPr algn="l"/>
+                      <a:r>
+                        <a:rPr sz="1100" b="1" i="0">
+                          <a:solidFill>
+                            <a:srgbClr val="FFFFFF"/>
+                          </a:solidFill>
+                          <a:latin typeface="Calibri"/>
+                        </a:rPr>
+                        <a:t>Monthly cost (INR)</a:t>
+                      </a:r>
+                    </a:p>
+                  </a:txBody>
+                  <a:tcPr anchor="ctr" marL="73152" marR="73152" marT="18288" marB="18288">
+                    <a:solidFill>
+                      <a:srgbClr val="00584C"/>
+                    </a:solidFill>
+                  </a:tcPr>
+                </a:tc>
+                <a:tc>
+                  <a:txBody>
+                    <a:bodyPr wrap="square"/>
+                    <a:lstStyle/>
+                    <a:p>
+                      <a:pPr algn="l"/>
+                      <a:r>
+                        <a:rPr sz="1100" b="1" i="0">
+                          <a:solidFill>
+                            <a:srgbClr val="FFFFFF"/>
+                          </a:solidFill>
+                          <a:latin typeface="Calibri"/>
+                        </a:rPr>
+                        <a:t>Notes</a:t>
+                      </a:r>
+                    </a:p>
+                  </a:txBody>
+                  <a:tcPr anchor="ctr" marL="73152" marR="73152" marT="18288" marB="18288">
+                    <a:solidFill>
+                      <a:srgbClr val="00584C"/>
+                    </a:solidFill>
+                  </a:tcPr>
+                </a:tc>
+              </a:tr>
+              <a:tr h="402336">
+                <a:tc>
+                  <a:txBody>
+                    <a:bodyPr wrap="square"/>
+                    <a:lstStyle/>
+                    <a:p>
+                      <a:pPr algn="l"/>
+                      <a:r>
+                        <a:rPr sz="1050" b="0" i="0">
+                          <a:solidFill>
+                            <a:srgbClr val="0E201B"/>
+                          </a:solidFill>
+                          <a:latin typeface="Calibri"/>
+                        </a:rPr>
+                        <a:t>Compute (EC2 / serverless)</a:t>
+                      </a:r>
+                    </a:p>
+                  </a:txBody>
+                  <a:tcPr anchor="ctr" marL="73152" marR="73152" marT="18288" marB="18288">
+                    <a:solidFill>
+                      <a:srgbClr val="FFFFFF"/>
+                    </a:solidFill>
+                  </a:tcPr>
+                </a:tc>
+                <a:tc>
+                  <a:txBody>
+                    <a:bodyPr wrap="square"/>
+                    <a:lstStyle/>
+                    <a:p>
+                      <a:pPr algn="l"/>
+                      <a:r>
+                        <a:rPr sz="1050" b="1" i="0">
+                          <a:solidFill>
+                            <a:srgbClr val="0E201B"/>
+                          </a:solidFill>
+                          <a:latin typeface="Calibri"/>
+                        </a:rPr>
+                        <a:t>₹15,000</a:t>
+                      </a:r>
+                    </a:p>
+                  </a:txBody>
+                  <a:tcPr anchor="ctr" marL="73152" marR="73152" marT="18288" marB="18288">
+                    <a:solidFill>
+                      <a:srgbClr val="FFFFFF"/>
+                    </a:solidFill>
+                  </a:tcPr>
+                </a:tc>
+                <a:tc>
+                  <a:txBody>
+                    <a:bodyPr wrap="square"/>
+                    <a:lstStyle/>
+                    <a:p>
+                      <a:pPr algn="l"/>
+                      <a:r>
+                        <a:rPr sz="1000" b="0" i="0">
+                          <a:solidFill>
+                            <a:srgbClr val="55645F"/>
+                          </a:solidFill>
+                          <a:latin typeface="Calibri"/>
+                        </a:rPr>
+                        <a:t>Spot instances, auto-scaling</a:t>
+                      </a:r>
+                    </a:p>
+                  </a:txBody>
+                  <a:tcPr anchor="ctr" marL="73152" marR="73152" marT="18288" marB="18288">
+                    <a:solidFill>
+                      <a:srgbClr val="FFFFFF"/>
+                    </a:solidFill>
+                  </a:tcPr>
+                </a:tc>
+              </a:tr>
+              <a:tr h="402336">
+                <a:tc>
+                  <a:txBody>
+                    <a:bodyPr wrap="square"/>
+                    <a:lstStyle/>
+                    <a:p>
+                      <a:pPr algn="l"/>
+                      <a:r>
+                        <a:rPr sz="1050" b="0" i="0">
+                          <a:solidFill>
+                            <a:srgbClr val="0E201B"/>
+                          </a:solidFill>
+                          <a:latin typeface="Calibri"/>
+                        </a:rPr>
+                        <a:t>Storage (S3 data lake)</a:t>
+                      </a:r>
+                    </a:p>
+                  </a:txBody>
+                  <a:tcPr anchor="ctr" marL="73152" marR="73152" marT="18288" marB="18288">
+                    <a:solidFill>
+                      <a:srgbClr val="FFFFFF"/>
+                    </a:solidFill>
+                  </a:tcPr>
+                </a:tc>
+                <a:tc>
+                  <a:txBody>
+                    <a:bodyPr wrap="square"/>
+                    <a:lstStyle/>
+                    <a:p>
+                      <a:pPr algn="l"/>
+                      <a:r>
+                        <a:rPr sz="1050" b="1" i="0">
+                          <a:solidFill>
+                            <a:srgbClr val="0E201B"/>
+                          </a:solidFill>
+                          <a:latin typeface="Calibri"/>
+                        </a:rPr>
+                        <a:t>₹2,100</a:t>
+                      </a:r>
+                    </a:p>
+                  </a:txBody>
+                  <a:tcPr anchor="ctr" marL="73152" marR="73152" marT="18288" marB="18288">
+                    <a:solidFill>
+                      <a:srgbClr val="FFFFFF"/>
+                    </a:solidFill>
+                  </a:tcPr>
+                </a:tc>
+                <a:tc>
+                  <a:txBody>
+                    <a:bodyPr wrap="square"/>
+                    <a:lstStyle/>
+                    <a:p>
+                      <a:pPr algn="l"/>
+                      <a:r>
+                        <a:rPr sz="1000" b="0" i="0">
+                          <a:solidFill>
+                            <a:srgbClr val="55645F"/>
+                          </a:solidFill>
+                          <a:latin typeface="Calibri"/>
+                        </a:rPr>
+                        <a:t>1 TB transaction data</a:t>
+                      </a:r>
+                    </a:p>
+                  </a:txBody>
+                  <a:tcPr anchor="ctr" marL="73152" marR="73152" marT="18288" marB="18288">
+                    <a:solidFill>
+                      <a:srgbClr val="FFFFFF"/>
+                    </a:solidFill>
+                  </a:tcPr>
+                </a:tc>
+              </a:tr>
+              <a:tr h="402336">
+                <a:tc>
+                  <a:txBody>
+                    <a:bodyPr wrap="square"/>
+                    <a:lstStyle/>
+                    <a:p>
+                      <a:pPr algn="l"/>
+                      <a:r>
+                        <a:rPr sz="1050" b="0" i="0">
+                          <a:solidFill>
+                            <a:srgbClr val="0E201B"/>
+                          </a:solidFill>
+                          <a:latin typeface="Calibri"/>
+                        </a:rPr>
+                        <a:t>ETL (Glue / Spark)</a:t>
+                      </a:r>
+                    </a:p>
+                  </a:txBody>
+                  <a:tcPr anchor="ctr" marL="73152" marR="73152" marT="18288" marB="18288">
+                    <a:solidFill>
+                      <a:srgbClr val="FFFFFF"/>
+                    </a:solidFill>
+                  </a:tcPr>
+                </a:tc>
+                <a:tc>
+                  <a:txBody>
+                    <a:bodyPr wrap="square"/>
+                    <a:lstStyle/>
+                    <a:p>
+                      <a:pPr algn="l"/>
+                      <a:r>
+                        <a:rPr sz="1050" b="1" i="0">
+                          <a:solidFill>
+                            <a:srgbClr val="0E201B"/>
+                          </a:solidFill>
+                          <a:latin typeface="Calibri"/>
+                        </a:rPr>
+                        <a:t>₹6,700</a:t>
+                      </a:r>
+                    </a:p>
+                  </a:txBody>
+                  <a:tcPr anchor="ctr" marL="73152" marR="73152" marT="18288" marB="18288">
+                    <a:solidFill>
+                      <a:srgbClr val="FFFFFF"/>
+                    </a:solidFill>
+                  </a:tcPr>
+                </a:tc>
+                <a:tc>
+                  <a:txBody>
+                    <a:bodyPr wrap="square"/>
+                    <a:lstStyle/>
+                    <a:p>
+                      <a:pPr algn="l"/>
+                      <a:r>
+                        <a:rPr sz="1000" b="0" i="0">
+                          <a:solidFill>
+                            <a:srgbClr val="55645F"/>
+                          </a:solidFill>
+                          <a:latin typeface="Calibri"/>
+                        </a:rPr>
+                        <a:t>Daily batch jobs</a:t>
+                      </a:r>
+                    </a:p>
+                  </a:txBody>
+                  <a:tcPr anchor="ctr" marL="73152" marR="73152" marT="18288" marB="18288">
+                    <a:solidFill>
+                      <a:srgbClr val="FFFFFF"/>
+                    </a:solidFill>
+                  </a:tcPr>
+                </a:tc>
+              </a:tr>
+              <a:tr h="402336">
+                <a:tc>
+                  <a:txBody>
+                    <a:bodyPr wrap="square"/>
+                    <a:lstStyle/>
+                    <a:p>
+                      <a:pPr algn="l"/>
+                      <a:r>
+                        <a:rPr sz="1050" b="0" i="0">
+                          <a:solidFill>
+                            <a:srgbClr val="0E201B"/>
+                          </a:solidFill>
+                          <a:latin typeface="Calibri"/>
+                        </a:rPr>
+                        <a:t>ML training (SageMaker)</a:t>
+                      </a:r>
+                    </a:p>
+                  </a:txBody>
+                  <a:tcPr anchor="ctr" marL="73152" marR="73152" marT="18288" marB="18288">
+                    <a:solidFill>
+                      <a:srgbClr val="FFFFFF"/>
+                    </a:solidFill>
+                  </a:tcPr>
+                </a:tc>
+                <a:tc>
+                  <a:txBody>
+                    <a:bodyPr wrap="square"/>
+                    <a:lstStyle/>
+                    <a:p>
+                      <a:pPr algn="l"/>
+                      <a:r>
+                        <a:rPr sz="1050" b="1" i="0">
+                          <a:solidFill>
+                            <a:srgbClr val="0E201B"/>
+                          </a:solidFill>
+                          <a:latin typeface="Calibri"/>
+                        </a:rPr>
+                        <a:t>₹10,000</a:t>
+                      </a:r>
+                    </a:p>
+                  </a:txBody>
+                  <a:tcPr anchor="ctr" marL="73152" marR="73152" marT="18288" marB="18288">
+                    <a:solidFill>
+                      <a:srgbClr val="FFFFFF"/>
+                    </a:solidFill>
+                  </a:tcPr>
+                </a:tc>
+                <a:tc>
+                  <a:txBody>
+                    <a:bodyPr wrap="square"/>
+                    <a:lstStyle/>
+                    <a:p>
+                      <a:pPr algn="l"/>
+                      <a:r>
+                        <a:rPr sz="1000" b="0" i="0">
+                          <a:solidFill>
+                            <a:srgbClr val="55645F"/>
+                          </a:solidFill>
+                          <a:latin typeface="Calibri"/>
+                        </a:rPr>
+                        <a:t>Weekly retraining, spot pricing</a:t>
+                      </a:r>
+                    </a:p>
+                  </a:txBody>
+                  <a:tcPr anchor="ctr" marL="73152" marR="73152" marT="18288" marB="18288">
+                    <a:solidFill>
+                      <a:srgbClr val="FFFFFF"/>
+                    </a:solidFill>
+                  </a:tcPr>
+                </a:tc>
+              </a:tr>
+              <a:tr h="402336">
+                <a:tc>
+                  <a:txBody>
+                    <a:bodyPr wrap="square"/>
+                    <a:lstStyle/>
+                    <a:p>
+                      <a:pPr algn="l"/>
+                      <a:r>
+                        <a:rPr sz="1050" b="0" i="0">
+                          <a:solidFill>
+                            <a:srgbClr val="0E201B"/>
+                          </a:solidFill>
+                          <a:latin typeface="Calibri"/>
+                        </a:rPr>
+                        <a:t>ML inference (batch transform)</a:t>
+                      </a:r>
+                    </a:p>
+                  </a:txBody>
+                  <a:tcPr anchor="ctr" marL="73152" marR="73152" marT="18288" marB="18288">
+                    <a:solidFill>
+                      <a:srgbClr val="FFFFFF"/>
+                    </a:solidFill>
+                  </a:tcPr>
+                </a:tc>
+                <a:tc>
+                  <a:txBody>
+                    <a:bodyPr wrap="square"/>
+                    <a:lstStyle/>
+                    <a:p>
+                      <a:pPr algn="l"/>
+                      <a:r>
+                        <a:rPr sz="1050" b="1" i="0">
+                          <a:solidFill>
+                            <a:srgbClr val="0E201B"/>
+                          </a:solidFill>
+                          <a:latin typeface="Calibri"/>
+                        </a:rPr>
+                        <a:t>₹12,500</a:t>
+                      </a:r>
+                    </a:p>
+                  </a:txBody>
+                  <a:tcPr anchor="ctr" marL="73152" marR="73152" marT="18288" marB="18288">
+                    <a:solidFill>
+                      <a:srgbClr val="FFFFFF"/>
+                    </a:solidFill>
+                  </a:tcPr>
+                </a:tc>
+                <a:tc>
+                  <a:txBody>
+                    <a:bodyPr wrap="square"/>
+                    <a:lstStyle/>
+                    <a:p>
+                      <a:pPr algn="l"/>
+                      <a:r>
+                        <a:rPr sz="1000" b="0" i="0">
+                          <a:solidFill>
+                            <a:srgbClr val="55645F"/>
+                          </a:solidFill>
+                          <a:latin typeface="Calibri"/>
+                        </a:rPr>
+                        <a:t>Nightly scoring, no real-time endpoints</a:t>
+                      </a:r>
+                    </a:p>
+                  </a:txBody>
+                  <a:tcPr anchor="ctr" marL="73152" marR="73152" marT="18288" marB="18288">
+                    <a:solidFill>
+                      <a:srgbClr val="FFFFFF"/>
+                    </a:solidFill>
+                  </a:tcPr>
+                </a:tc>
+              </a:tr>
+              <a:tr h="402336">
+                <a:tc>
+                  <a:txBody>
+                    <a:bodyPr wrap="square"/>
+                    <a:lstStyle/>
+                    <a:p>
+                      <a:pPr algn="l"/>
+                      <a:r>
+                        <a:rPr sz="1050" b="0" i="0">
+                          <a:solidFill>
+                            <a:srgbClr val="0E201B"/>
+                          </a:solidFill>
+                          <a:latin typeface="Calibri"/>
+                        </a:rPr>
+                        <a:t>Cache (ElastiCache)</a:t>
+                      </a:r>
+                    </a:p>
+                  </a:txBody>
+                  <a:tcPr anchor="ctr" marL="73152" marR="73152" marT="18288" marB="18288">
+                    <a:solidFill>
+                      <a:srgbClr val="FFFFFF"/>
+                    </a:solidFill>
+                  </a:tcPr>
+                </a:tc>
+                <a:tc>
+                  <a:txBody>
+                    <a:bodyPr wrap="square"/>
+                    <a:lstStyle/>
+                    <a:p>
+                      <a:pPr algn="l"/>
+                      <a:r>
+                        <a:rPr sz="1050" b="1" i="0">
+                          <a:solidFill>
+                            <a:srgbClr val="0E201B"/>
+                          </a:solidFill>
+                          <a:latin typeface="Calibri"/>
+                        </a:rPr>
+                        <a:t>₹3,300</a:t>
+                      </a:r>
+                    </a:p>
+                  </a:txBody>
+                  <a:tcPr anchor="ctr" marL="73152" marR="73152" marT="18288" marB="18288">
+                    <a:solidFill>
+                      <a:srgbClr val="FFFFFF"/>
+                    </a:solidFill>
+                  </a:tcPr>
+                </a:tc>
+                <a:tc>
+                  <a:txBody>
+                    <a:bodyPr wrap="square"/>
+                    <a:lstStyle/>
+                    <a:p>
+                      <a:pPr algn="l"/>
+                      <a:r>
+                        <a:rPr sz="1000" b="0" i="0">
+                          <a:solidFill>
+                            <a:srgbClr val="55645F"/>
+                          </a:solidFill>
+                          <a:latin typeface="Calibri"/>
+                        </a:rPr>
+                        <a:t>Real-time intent signals</a:t>
+                      </a:r>
+                    </a:p>
+                  </a:txBody>
+                  <a:tcPr anchor="ctr" marL="73152" marR="73152" marT="18288" marB="18288">
+                    <a:solidFill>
+                      <a:srgbClr val="FFFFFF"/>
+                    </a:solidFill>
+                  </a:tcPr>
+                </a:tc>
+              </a:tr>
+              <a:tr h="402336">
+                <a:tc>
+                  <a:txBody>
+                    <a:bodyPr wrap="square"/>
+                    <a:lstStyle/>
+                    <a:p>
+                      <a:pPr algn="l"/>
+                      <a:r>
+                        <a:rPr sz="1050" b="0" i="0">
+                          <a:solidFill>
+                            <a:srgbClr val="0E201B"/>
+                          </a:solidFill>
+                          <a:latin typeface="Calibri"/>
+                        </a:rPr>
+                        <a:t>Database (RDS / Aurora)</a:t>
+                      </a:r>
+                    </a:p>
+                  </a:txBody>
+                  <a:tcPr anchor="ctr" marL="73152" marR="73152" marT="18288" marB="18288">
+                    <a:solidFill>
+                      <a:srgbClr val="FFFFFF"/>
+                    </a:solidFill>
+                  </a:tcPr>
+                </a:tc>
+                <a:tc>
+                  <a:txBody>
+                    <a:bodyPr wrap="square"/>
+                    <a:lstStyle/>
+                    <a:p>
+                      <a:pPr algn="l"/>
+                      <a:r>
+                        <a:rPr sz="1050" b="1" i="0">
+                          <a:solidFill>
+                            <a:srgbClr val="0E201B"/>
+                          </a:solidFill>
+                          <a:latin typeface="Calibri"/>
+                        </a:rPr>
+                        <a:t>₹5,000</a:t>
+                      </a:r>
+                    </a:p>
+                  </a:txBody>
+                  <a:tcPr anchor="ctr" marL="73152" marR="73152" marT="18288" marB="18288">
+                    <a:solidFill>
+                      <a:srgbClr val="FFFFFF"/>
+                    </a:solidFill>
+                  </a:tcPr>
+                </a:tc>
+                <a:tc>
+                  <a:txBody>
+                    <a:bodyPr wrap="square"/>
+                    <a:lstStyle/>
+                    <a:p>
+                      <a:pPr algn="l"/>
+                      <a:r>
+                        <a:rPr sz="1000" b="0" i="0">
+                          <a:solidFill>
+                            <a:srgbClr val="55645F"/>
+                          </a:solidFill>
+                          <a:latin typeface="Calibri"/>
+                        </a:rPr>
+                        <a:t>Episodic + document store</a:t>
+                      </a:r>
+                    </a:p>
+                  </a:txBody>
+                  <a:tcPr anchor="ctr" marL="73152" marR="73152" marT="18288" marB="18288">
+                    <a:solidFill>
+                      <a:srgbClr val="FFFFFF"/>
+                    </a:solidFill>
+                  </a:tcPr>
+                </a:tc>
+              </a:tr>
+              <a:tr h="402336">
+                <a:tc>
+                  <a:txBody>
+                    <a:bodyPr wrap="square"/>
+                    <a:lstStyle/>
+                    <a:p>
+                      <a:pPr algn="l"/>
+                      <a:r>
+                        <a:rPr sz="1050" b="0" i="0">
+                          <a:solidFill>
+                            <a:srgbClr val="0E201B"/>
+                          </a:solidFill>
+                          <a:latin typeface="Calibri"/>
+                        </a:rPr>
+                        <a:t>Vector + graph DB</a:t>
+                      </a:r>
+                    </a:p>
+                  </a:txBody>
+                  <a:tcPr anchor="ctr" marL="73152" marR="73152" marT="18288" marB="18288">
+                    <a:solidFill>
+                      <a:srgbClr val="FFFFFF"/>
+                    </a:solidFill>
+                  </a:tcPr>
+                </a:tc>
+                <a:tc>
+                  <a:txBody>
+                    <a:bodyPr wrap="square"/>
+                    <a:lstStyle/>
+                    <a:p>
+                      <a:pPr algn="l"/>
+                      <a:r>
+                        <a:rPr sz="1050" b="1" i="0">
+                          <a:solidFill>
+                            <a:srgbClr val="0E201B"/>
+                          </a:solidFill>
+                          <a:latin typeface="Calibri"/>
+                        </a:rPr>
+                        <a:t>₹6,700</a:t>
+                      </a:r>
+                    </a:p>
+                  </a:txBody>
+                  <a:tcPr anchor="ctr" marL="73152" marR="73152" marT="18288" marB="18288">
+                    <a:solidFill>
+                      <a:srgbClr val="FFFFFF"/>
+                    </a:solidFill>
+                  </a:tcPr>
+                </a:tc>
+                <a:tc>
+                  <a:txBody>
+                    <a:bodyPr wrap="square"/>
+                    <a:lstStyle/>
+                    <a:p>
+                      <a:pPr algn="l"/>
+                      <a:r>
+                        <a:rPr sz="1000" b="0" i="0">
+                          <a:solidFill>
+                            <a:srgbClr val="55645F"/>
+                          </a:solidFill>
+                          <a:latin typeface="Calibri"/>
+                        </a:rPr>
+                        <a:t>Qdrant + Neo4j on EC2</a:t>
+                      </a:r>
+                    </a:p>
+                  </a:txBody>
+                  <a:tcPr anchor="ctr" marL="73152" marR="73152" marT="18288" marB="18288">
+                    <a:solidFill>
+                      <a:srgbClr val="FFFFFF"/>
+                    </a:solidFill>
+                  </a:tcPr>
+                </a:tc>
+              </a:tr>
+              <a:tr h="402336">
+                <a:tc>
+                  <a:txBody>
+                    <a:bodyPr wrap="square"/>
+                    <a:lstStyle/>
+                    <a:p>
+                      <a:pPr algn="l"/>
+                      <a:r>
+                        <a:rPr sz="1050" b="0" i="0">
+                          <a:solidFill>
+                            <a:srgbClr val="0E201B"/>
+                          </a:solidFill>
+                          <a:latin typeface="Calibri"/>
+                        </a:rPr>
+                        <a:t>Monitoring (CloudWatch)</a:t>
+                      </a:r>
+                    </a:p>
+                  </a:txBody>
+                  <a:tcPr anchor="ctr" marL="73152" marR="73152" marT="18288" marB="18288">
+                    <a:solidFill>
+                      <a:srgbClr val="FFFFFF"/>
+                    </a:solidFill>
+                  </a:tcPr>
+                </a:tc>
+                <a:tc>
+                  <a:txBody>
+                    <a:bodyPr wrap="square"/>
+                    <a:lstStyle/>
+                    <a:p>
+                      <a:pPr algn="l"/>
+                      <a:r>
+                        <a:rPr sz="1050" b="1" i="0">
+                          <a:solidFill>
+                            <a:srgbClr val="0E201B"/>
+                          </a:solidFill>
+                          <a:latin typeface="Calibri"/>
+                        </a:rPr>
+                        <a:t>₹2,100</a:t>
+                      </a:r>
+                    </a:p>
+                  </a:txBody>
+                  <a:tcPr anchor="ctr" marL="73152" marR="73152" marT="18288" marB="18288">
+                    <a:solidFill>
+                      <a:srgbClr val="FFFFFF"/>
+                    </a:solidFill>
+                  </a:tcPr>
+                </a:tc>
+                <a:tc>
+                  <a:txBody>
+                    <a:bodyPr wrap="square"/>
+                    <a:lstStyle/>
+                    <a:p>
+                      <a:pPr algn="l"/>
+                      <a:r>
+                        <a:rPr sz="1000" b="0" i="0">
+                          <a:solidFill>
+                            <a:srgbClr val="55645F"/>
+                          </a:solidFill>
+                          <a:latin typeface="Calibri"/>
+                        </a:rPr>
+                        <a:t>Observability stack</a:t>
+                      </a:r>
+                    </a:p>
+                  </a:txBody>
+                  <a:tcPr anchor="ctr" marL="73152" marR="73152" marT="18288" marB="18288">
+                    <a:solidFill>
+                      <a:srgbClr val="FFFFFF"/>
+                    </a:solidFill>
+                  </a:tcPr>
+                </a:tc>
+              </a:tr>
+              <a:tr h="402336">
+                <a:tc>
+                  <a:txBody>
+                    <a:bodyPr wrap="square"/>
+                    <a:lstStyle/>
+                    <a:p>
+                      <a:pPr algn="l"/>
+                      <a:r>
+                        <a:rPr sz="1050" b="1" i="0">
+                          <a:solidFill>
+                            <a:srgbClr val="0E201B"/>
+                          </a:solidFill>
+                          <a:latin typeface="Calibri"/>
+                        </a:rPr>
+                        <a:t>Total monthly</a:t>
+                      </a:r>
+                    </a:p>
+                  </a:txBody>
+                  <a:tcPr anchor="ctr" marL="73152" marR="73152" marT="18288" marB="18288">
+                    <a:solidFill>
+                      <a:srgbClr val="EAF4F1"/>
+                    </a:solidFill>
+                  </a:tcPr>
+                </a:tc>
+                <a:tc>
+                  <a:txBody>
+                    <a:bodyPr wrap="square"/>
+                    <a:lstStyle/>
+                    <a:p>
+                      <a:pPr algn="l"/>
+                      <a:r>
+                        <a:rPr sz="1050" b="1" i="0">
+                          <a:solidFill>
+                            <a:srgbClr val="00584C"/>
+                          </a:solidFill>
+                          <a:latin typeface="Calibri"/>
+                        </a:rPr>
+                        <a:t>~₹50,900</a:t>
+                      </a:r>
+                    </a:p>
+                  </a:txBody>
+                  <a:tcPr anchor="ctr" marL="73152" marR="73152" marT="18288" marB="18288">
+                    <a:solidFill>
+                      <a:srgbClr val="EAF4F1"/>
+                    </a:solidFill>
+                  </a:tcPr>
+                </a:tc>
+                <a:tc>
+                  <a:txBody>
+                    <a:bodyPr wrap="square"/>
+                    <a:lstStyle/>
+                    <a:p>
+                      <a:pPr algn="l"/>
+                      <a:r>
+                        <a:rPr sz="1000" b="0" i="1">
+                          <a:solidFill>
+                            <a:srgbClr val="55645F"/>
+                          </a:solidFill>
+                          <a:latin typeface="Calibri"/>
+                        </a:rPr>
+                        <a:t>Well within pilot budget</a:t>
+                      </a:r>
+                    </a:p>
+                  </a:txBody>
+                  <a:tcPr anchor="ctr" marL="73152" marR="73152" marT="18288" marB="18288">
+                    <a:solidFill>
+                      <a:srgbClr val="EAF4F1"/>
+                    </a:solidFill>
+                  </a:tcPr>
+                </a:tc>
+              </a:tr>
+            </a:tbl>
+          </a:graphicData>
+        </a:graphic>
+      </p:graphicFrame>
+      <p:sp>
+        <p:nvSpPr>
+          <p:cNvPr id="6" name="TextBox 5"/>
+          <p:cNvSpPr txBox="1"/>
+          <p:nvPr/>
+        </p:nvSpPr>
+        <p:spPr>
+          <a:xfrm>
+            <a:off x="7178040" y="1755648"/>
+            <a:ext cx="4480560" cy="365760"/>
+          </a:xfrm>
+          <a:prstGeom prst="rect">
+            <a:avLst/>
+          </a:prstGeom>
+          <a:noFill/>
+        </p:spPr>
+        <p:txBody>
+          <a:bodyPr wrap="square" anchor="t" lIns="0" rIns="0" tIns="0" bIns="0">
+            <a:spAutoFit/>
+          </a:bodyPr>
+          <a:lstStyle/>
+          <a:p>
+            <a:pPr algn="l">
+              <a:lnSpc>
+                <a:spcPct val="105000"/>
+              </a:lnSpc>
+            </a:pPr>
+            <a:r>
+              <a:rPr sz="1500" b="1" i="0">
+                <a:solidFill>
+                  <a:srgbClr val="C77700"/>
+                </a:solidFill>
+                <a:latin typeface="Arial"/>
+              </a:rPr>
+              <a:t>Unit economics</a:t>
+            </a:r>
+          </a:p>
+        </p:txBody>
+      </p:sp>
+      <p:graphicFrame>
+        <p:nvGraphicFramePr>
+          <p:cNvPr id="7" name="Table 6"/>
+          <p:cNvGraphicFramePr>
+            <a:graphicFrameLocks noGrp="1"/>
+          </p:cNvGraphicFramePr>
+          <p:nvPr/>
+        </p:nvGraphicFramePr>
+        <p:xfrm>
+          <a:off x="7178040" y="2176272"/>
+          <a:ext cx="4480560" cy="2414016"/>
+        </p:xfrm>
+        <a:graphic>
+          <a:graphicData uri="http://schemas.openxmlformats.org/drawingml/2006/table">
+            <a:tbl>
+              <a:tblPr firstRow="1" bandRow="0">
+                <a:tableStyleId>{5940675A-B579-460E-94D1-54222C63F5DA}</a:tableStyleId>
+              </a:tblPr>
+              <a:tblGrid>
+                <a:gridCol w="2331720"/>
+                <a:gridCol w="2148840"/>
+              </a:tblGrid>
+              <a:tr h="402336">
+                <a:tc>
+                  <a:txBody>
+                    <a:bodyPr wrap="square"/>
+                    <a:lstStyle/>
+                    <a:p>
+                      <a:pPr algn="l"/>
+                      <a:r>
+                        <a:rPr sz="1100" b="1" i="0">
+                          <a:solidFill>
+                            <a:srgbClr val="FFFFFF"/>
+                          </a:solidFill>
+                          <a:latin typeface="Calibri"/>
+                        </a:rPr>
+                        <a:t>Metric</a:t>
+                      </a:r>
+                    </a:p>
+                  </a:txBody>
+                  <a:tcPr anchor="ctr" marL="73152" marR="73152" marT="18288" marB="18288">
+                    <a:solidFill>
+                      <a:srgbClr val="00584C"/>
+                    </a:solidFill>
+                  </a:tcPr>
+                </a:tc>
+                <a:tc>
+                  <a:txBody>
+                    <a:bodyPr wrap="square"/>
+                    <a:lstStyle/>
+                    <a:p>
+                      <a:pPr algn="l"/>
+                      <a:r>
+                        <a:rPr sz="1100" b="1" i="0">
+                          <a:solidFill>
+                            <a:srgbClr val="FFFFFF"/>
+                          </a:solidFill>
+                          <a:latin typeface="Calibri"/>
+                        </a:rPr>
+                        <a:t>Value</a:t>
+                      </a:r>
+                    </a:p>
+                  </a:txBody>
+                  <a:tcPr anchor="ctr" marL="73152" marR="73152" marT="18288" marB="18288">
+                    <a:solidFill>
+                      <a:srgbClr val="00584C"/>
+                    </a:solidFill>
+                  </a:tcPr>
+                </a:tc>
+              </a:tr>
+              <a:tr h="402336">
+                <a:tc>
+                  <a:txBody>
+                    <a:bodyPr wrap="square"/>
+                    <a:lstStyle/>
+                    <a:p>
+                      <a:pPr algn="l"/>
+                      <a:r>
+                        <a:rPr sz="1050" b="0" i="0">
+                          <a:solidFill>
+                            <a:srgbClr val="0E201B"/>
+                          </a:solidFill>
+                          <a:latin typeface="Calibri"/>
+                        </a:rPr>
+                        <a:t>Cost / lead scored</a:t>
+                      </a:r>
+                    </a:p>
+                  </a:txBody>
+                  <a:tcPr anchor="ctr" marL="73152" marR="73152" marT="18288" marB="18288">
+                    <a:solidFill>
+                      <a:srgbClr val="FFFFFF"/>
+                    </a:solidFill>
+                  </a:tcPr>
+                </a:tc>
+                <a:tc>
+                  <a:txBody>
+                    <a:bodyPr wrap="square"/>
+                    <a:lstStyle/>
+                    <a:p>
+                      <a:pPr algn="l"/>
+                      <a:r>
+                        <a:rPr sz="1050" b="1" i="0">
+                          <a:solidFill>
+                            <a:srgbClr val="0E201B"/>
+                          </a:solidFill>
+                          <a:latin typeface="Calibri"/>
+                        </a:rPr>
+                        <a:t>₹0.51  (10× cheaper)</a:t>
+                      </a:r>
+                    </a:p>
+                  </a:txBody>
+                  <a:tcPr anchor="ctr" marL="73152" marR="73152" marT="18288" marB="18288">
+                    <a:solidFill>
+                      <a:srgbClr val="FFFFFF"/>
+                    </a:solidFill>
+                  </a:tcPr>
+                </a:tc>
+              </a:tr>
+              <a:tr h="402336">
+                <a:tc>
+                  <a:txBody>
+                    <a:bodyPr wrap="square"/>
+                    <a:lstStyle/>
+                    <a:p>
+                      <a:pPr algn="l"/>
+                      <a:r>
+                        <a:rPr sz="1050" b="0" i="0">
+                          <a:solidFill>
+                            <a:srgbClr val="0E201B"/>
+                          </a:solidFill>
+                          <a:latin typeface="Calibri"/>
+                        </a:rPr>
+                        <a:t>Cost / conversion</a:t>
+                      </a:r>
+                    </a:p>
+                  </a:txBody>
+                  <a:tcPr anchor="ctr" marL="73152" marR="73152" marT="18288" marB="18288">
+                    <a:solidFill>
+                      <a:srgbClr val="FFFFFF"/>
+                    </a:solidFill>
+                  </a:tcPr>
+                </a:tc>
+                <a:tc>
+                  <a:txBody>
+                    <a:bodyPr wrap="square"/>
+                    <a:lstStyle/>
+                    <a:p>
+                      <a:pPr algn="l"/>
+                      <a:r>
+                        <a:rPr sz="1050" b="1" i="0">
+                          <a:solidFill>
+                            <a:srgbClr val="0E201B"/>
+                          </a:solidFill>
+                          <a:latin typeface="Calibri"/>
+                        </a:rPr>
+                        <a:t>₹170  (3× cheaper)</a:t>
+                      </a:r>
+                    </a:p>
+                  </a:txBody>
+                  <a:tcPr anchor="ctr" marL="73152" marR="73152" marT="18288" marB="18288">
+                    <a:solidFill>
+                      <a:srgbClr val="FFFFFF"/>
+                    </a:solidFill>
+                  </a:tcPr>
+                </a:tc>
+              </a:tr>
+              <a:tr h="402336">
+                <a:tc>
+                  <a:txBody>
+                    <a:bodyPr wrap="square"/>
+                    <a:lstStyle/>
+                    <a:p>
+                      <a:pPr algn="l"/>
+                      <a:r>
+                        <a:rPr sz="1050" b="0" i="0">
+                          <a:solidFill>
+                            <a:srgbClr val="0E201B"/>
+                          </a:solidFill>
+                          <a:latin typeface="Calibri"/>
+                        </a:rPr>
+                        <a:t>Cost / loan disbursed</a:t>
+                      </a:r>
+                    </a:p>
+                  </a:txBody>
+                  <a:tcPr anchor="ctr" marL="73152" marR="73152" marT="18288" marB="18288">
+                    <a:solidFill>
+                      <a:srgbClr val="FFFFFF"/>
+                    </a:solidFill>
+                  </a:tcPr>
+                </a:tc>
+                <a:tc>
+                  <a:txBody>
+                    <a:bodyPr wrap="square"/>
+                    <a:lstStyle/>
+                    <a:p>
+                      <a:pPr algn="l"/>
+                      <a:r>
+                        <a:rPr sz="1050" b="1" i="0">
+                          <a:solidFill>
+                            <a:srgbClr val="0E201B"/>
+                          </a:solidFill>
+                          <a:latin typeface="Calibri"/>
+                        </a:rPr>
+                        <a:t>₹1,700  (3–5× cheaper)</a:t>
+                      </a:r>
+                    </a:p>
+                  </a:txBody>
+                  <a:tcPr anchor="ctr" marL="73152" marR="73152" marT="18288" marB="18288">
+                    <a:solidFill>
+                      <a:srgbClr val="FFFFFF"/>
+                    </a:solidFill>
+                  </a:tcPr>
+                </a:tc>
+              </a:tr>
+              <a:tr h="402336">
+                <a:tc>
+                  <a:txBody>
+                    <a:bodyPr wrap="square"/>
+                    <a:lstStyle/>
+                    <a:p>
+                      <a:pPr algn="l"/>
+                      <a:r>
+                        <a:rPr sz="1050" b="0" i="0">
+                          <a:solidFill>
+                            <a:srgbClr val="0E201B"/>
+                          </a:solidFill>
+                          <a:latin typeface="Calibri"/>
+                        </a:rPr>
+                        <a:t>Revenue / lead (2% margin)</a:t>
+                      </a:r>
+                    </a:p>
+                  </a:txBody>
+                  <a:tcPr anchor="ctr" marL="73152" marR="73152" marT="18288" marB="18288">
+                    <a:solidFill>
+                      <a:srgbClr val="FFFFFF"/>
+                    </a:solidFill>
+                  </a:tcPr>
+                </a:tc>
+                <a:tc>
+                  <a:txBody>
+                    <a:bodyPr wrap="square"/>
+                    <a:lstStyle/>
+                    <a:p>
+                      <a:pPr algn="l"/>
+                      <a:r>
+                        <a:rPr sz="1050" b="1" i="0">
+                          <a:solidFill>
+                            <a:srgbClr val="0E201B"/>
+                          </a:solidFill>
+                          <a:latin typeface="Calibri"/>
+                        </a:rPr>
+                        <a:t>₹4,100  (3.4× higher)</a:t>
+                      </a:r>
+                    </a:p>
+                  </a:txBody>
+                  <a:tcPr anchor="ctr" marL="73152" marR="73152" marT="18288" marB="18288">
+                    <a:solidFill>
+                      <a:srgbClr val="FFFFFF"/>
+                    </a:solidFill>
+                  </a:tcPr>
+                </a:tc>
+              </a:tr>
+              <a:tr h="402336">
+                <a:tc>
+                  <a:txBody>
+                    <a:bodyPr wrap="square"/>
+                    <a:lstStyle/>
+                    <a:p>
+                      <a:pPr algn="l"/>
+                      <a:r>
+                        <a:rPr sz="1050" b="1" i="0">
+                          <a:solidFill>
+                            <a:srgbClr val="0E201B"/>
+                          </a:solidFill>
+                          <a:latin typeface="Calibri"/>
+                        </a:rPr>
+                        <a:t>ROI</a:t>
+                      </a:r>
+                    </a:p>
+                  </a:txBody>
+                  <a:tcPr anchor="ctr" marL="73152" marR="73152" marT="18288" marB="18288">
+                    <a:solidFill>
+                      <a:srgbClr val="EAF4F1"/>
+                    </a:solidFill>
+                  </a:tcPr>
+                </a:tc>
+                <a:tc>
+                  <a:txBody>
+                    <a:bodyPr wrap="square"/>
+                    <a:lstStyle/>
+                    <a:p>
+                      <a:pPr algn="l"/>
+                      <a:r>
+                        <a:rPr sz="1050" b="1" i="0">
+                          <a:solidFill>
+                            <a:srgbClr val="00584C"/>
+                          </a:solidFill>
+                          <a:latin typeface="Calibri"/>
+                        </a:rPr>
+                        <a:t>2.4×  (10× improvement)</a:t>
+                      </a:r>
+                    </a:p>
+                  </a:txBody>
+                  <a:tcPr anchor="ctr" marL="73152" marR="73152" marT="18288" marB="18288">
+                    <a:solidFill>
+                      <a:srgbClr val="EAF4F1"/>
+                    </a:solidFill>
+                  </a:tcPr>
+                </a:tc>
+              </a:tr>
+            </a:tbl>
+          </a:graphicData>
+        </a:graphic>
+      </p:graphicFrame>
+      <p:sp>
+        <p:nvSpPr>
+          <p:cNvPr id="8" name="Rounded Rectangle 7"/>
+          <p:cNvSpPr/>
+          <p:nvPr/>
+        </p:nvSpPr>
+        <p:spPr>
+          <a:xfrm>
+            <a:off x="7178040" y="4892040"/>
+            <a:ext cx="4480560" cy="960120"/>
+          </a:xfrm>
+          <a:prstGeom prst="roundRect">
+            <a:avLst>
+              <a:gd name="adj" fmla="val 12000"/>
+            </a:avLst>
+          </a:prstGeom>
+          <a:solidFill>
+            <a:srgbClr val="EAF4F1"/>
+          </a:solidFill>
+          <a:ln>
+            <a:noFill/>
+          </a:ln>
+        </p:spPr>
+        <p:style>
+          <a:lnRef idx="1">
+            <a:schemeClr val="accent1"/>
+          </a:lnRef>
+          <a:fillRef idx="3">
+            <a:schemeClr val="accent1"/>
+          </a:fillRef>
+          <a:effectRef idx="2">
+            <a:schemeClr val="accent1"/>
+          </a:effectRef>
+          <a:fontRef idx="minor">
+            <a:schemeClr val="lt1"/>
+          </a:fontRef>
+        </p:style>
+        <p:txBody>
+          <a:bodyPr rtlCol="0" anchor="ctr" wrap="square" lIns="228600" rIns="228600"/>
+          <a:lstStyle/>
+          <a:p>
+            <a:pPr algn="ctr"/>
+            <a:r>
+              <a:rPr sz="1200" b="1">
+                <a:solidFill>
+                  <a:srgbClr val="00584C"/>
+                </a:solidFill>
+                <a:latin typeface="Calibri"/>
+              </a:rPr>
+              <a:t>One-time setup:  </a:t>
+            </a:r>
+            <a:r>
+              <a:rPr sz="1200" b="0">
+                <a:solidFill>
+                  <a:srgbClr val="55645F"/>
+                </a:solidFill>
+                <a:latin typeface="Calibri"/>
+              </a:rPr>
+              <a:t>~₹41,700 for data migration &amp; initial model training.</a:t>
+            </a:r>
+          </a:p>
+        </p:txBody>
+      </p:sp>
+      <p:sp>
+        <p:nvSpPr>
+          <p:cNvPr id="9" name="TextBox 8"/>
+          <p:cNvSpPr txBox="1"/>
+          <p:nvPr/>
+        </p:nvSpPr>
+        <p:spPr>
+          <a:xfrm>
+            <a:off x="502920" y="6291072"/>
+            <a:ext cx="11155680" cy="274320"/>
+          </a:xfrm>
+          <a:prstGeom prst="rect">
+            <a:avLst/>
+          </a:prstGeom>
+          <a:noFill/>
+        </p:spPr>
+        <p:txBody>
+          <a:bodyPr wrap="square" anchor="t" lIns="0" rIns="0" tIns="0" bIns="0">
+            <a:spAutoFit/>
+          </a:bodyPr>
+          <a:lstStyle/>
+          <a:p>
+            <a:pPr algn="l">
+              <a:lnSpc>
+                <a:spcPct val="105000"/>
+              </a:lnSpc>
+            </a:pPr>
+            <a:r>
+              <a:rPr sz="1000" b="0" i="1">
+                <a:solidFill>
+                  <a:srgbClr val="55645F"/>
+                </a:solidFill>
+                <a:latin typeface="Calibri"/>
+              </a:rPr>
+              <a:t>Figures are indicative planning estimates; the data-source seam keeps re-platforming cost near zero between phases.</a:t>
+            </a:r>
+          </a:p>
+        </p:txBody>
+      </p:sp>
+      <p:sp>
+        <p:nvSpPr>
+          <p:cNvPr id="10" name="TextBox 9"/>
+          <p:cNvSpPr txBox="1"/>
+          <p:nvPr/>
+        </p:nvSpPr>
+        <p:spPr>
+          <a:xfrm>
+            <a:off x="502920" y="6473952"/>
+            <a:ext cx="5486400" cy="274320"/>
+          </a:xfrm>
+          <a:prstGeom prst="rect">
+            <a:avLst/>
+          </a:prstGeom>
+          <a:noFill/>
+        </p:spPr>
+        <p:txBody>
+          <a:bodyPr wrap="square" anchor="t" lIns="0" rIns="0" tIns="0" bIns="0">
+            <a:spAutoFit/>
+          </a:bodyPr>
+          <a:lstStyle/>
+          <a:p>
+            <a:pPr algn="l">
+              <a:lnSpc>
+                <a:spcPct val="105000"/>
+              </a:lnSpc>
+            </a:pPr>
+            <a:r>
+              <a:rPr sz="900" b="0" i="0">
+                <a:solidFill>
+                  <a:srgbClr val="55645F"/>
+                </a:solidFill>
+                <a:latin typeface="Calibri"/>
+              </a:rPr>
+              <a:t>Prospect Assist AI · IDBI Innovate 2026 · Track 2</a:t>
+            </a:r>
           </a:p>
         </p:txBody>
       </p:sp>

</xml_diff>

<commit_message>
Add GitHub and Render deployment links to deck
</commit_message>
<xml_diff>
--- a/Prospect_Assist_AI_Submission_Deck.pptx
+++ b/Prospect_Assist_AI_Submission_Deck.pptx
@@ -5168,15 +5168,14 @@
               <a:buNone/>
             </a:pPr>
             <a:r>
-              <a:rPr lang="en-US" sz="1300" dirty="0">
-                <a:solidFill>
-                  <a:srgbClr val="55645F"/>
-                </a:solidFill>
-                <a:latin typeface="Calibri" pitchFamily="34" charset="0"/>
-                <a:ea typeface="Calibri" pitchFamily="34" charset="-122"/>
-                <a:cs typeface="Calibri" pitchFamily="34" charset="-120"/>
-              </a:rPr>
-              <a:t>github.com/  ____________________________</a:t>
+              <a:rPr sz="1350" b="1">
+                <a:solidFill>
+                  <a:srgbClr val="00584C"/>
+                </a:solidFill>
+                <a:latin typeface="Calibri"/>
+                <a:hlinkClick r:id="rId3"/>
+              </a:rPr>
+              <a:t>github.com/KalithasG/prospect-assist-ai</a:t>
             </a:r>
             <a:endParaRPr lang="en-US" sz="1300" dirty="0"/>
           </a:p>
@@ -5392,15 +5391,14 @@
               <a:buNone/>
             </a:pPr>
             <a:r>
-              <a:rPr lang="en-US" sz="1300" dirty="0">
-                <a:solidFill>
-                  <a:srgbClr val="55645F"/>
-                </a:solidFill>
-                <a:latin typeface="Calibri" pitchFamily="34" charset="0"/>
-                <a:ea typeface="Calibri" pitchFamily="34" charset="-122"/>
-                <a:cs typeface="Calibri" pitchFamily="34" charset="-120"/>
-              </a:rPr>
-              <a:t>____________________________</a:t>
+              <a:rPr sz="1350" b="1">
+                <a:solidFill>
+                  <a:srgbClr val="00584C"/>
+                </a:solidFill>
+                <a:latin typeface="Calibri"/>
+                <a:hlinkClick r:id="rId4"/>
+              </a:rPr>
+              <a:t>prospect-assist-ai-brsg.onrender.com</a:t>
             </a:r>
             <a:endParaRPr lang="en-US" sz="1300" dirty="0"/>
           </a:p>

</xml_diff>